<commit_message>
Improve and add on content for latex report
</commit_message>
<xml_diff>
--- a/slides/slide_research.pptx
+++ b/slides/slide_research.pptx
@@ -5,25 +5,25 @@
     <p:sldMasterId id="2147483648" r:id="rId1"/>
   </p:sldMasterIdLst>
   <p:sldIdLst>
-    <p:sldId id="256" r:id="rId2"/>
-    <p:sldId id="257" r:id="rId3"/>
-    <p:sldId id="258" r:id="rId4"/>
-    <p:sldId id="259" r:id="rId5"/>
-    <p:sldId id="260" r:id="rId6"/>
-    <p:sldId id="261" r:id="rId7"/>
-    <p:sldId id="262" r:id="rId8"/>
-    <p:sldId id="263" r:id="rId9"/>
-    <p:sldId id="264" r:id="rId10"/>
-    <p:sldId id="265" r:id="rId11"/>
-    <p:sldId id="266" r:id="rId12"/>
-    <p:sldId id="267" r:id="rId13"/>
-    <p:sldId id="268" r:id="rId14"/>
-    <p:sldId id="269" r:id="rId15"/>
-    <p:sldId id="270" r:id="rId16"/>
-    <p:sldId id="271" r:id="rId17"/>
-    <p:sldId id="272" r:id="rId18"/>
+    <p:sldId id="256" r:id="rId7"/>
+    <p:sldId id="257" r:id="rId8"/>
+    <p:sldId id="258" r:id="rId9"/>
+    <p:sldId id="259" r:id="rId10"/>
+    <p:sldId id="260" r:id="rId11"/>
+    <p:sldId id="261" r:id="rId12"/>
+    <p:sldId id="262" r:id="rId13"/>
+    <p:sldId id="263" r:id="rId14"/>
+    <p:sldId id="264" r:id="rId15"/>
+    <p:sldId id="265" r:id="rId16"/>
+    <p:sldId id="266" r:id="rId17"/>
+    <p:sldId id="267" r:id="rId18"/>
+    <p:sldId id="268" r:id="rId19"/>
+    <p:sldId id="269" r:id="rId20"/>
+    <p:sldId id="270" r:id="rId21"/>
+    <p:sldId id="271" r:id="rId22"/>
+    <p:sldId id="272" r:id="rId23"/>
   </p:sldIdLst>
-  <p:sldSz cx="12192000" cy="6858000"/>
+  <p:sldSz cx="12191695" cy="6858000" type="screen4x3"/>
   <p:notesSz cx="6858000" cy="9144000"/>
   <p:defaultTextStyle>
     <a:defPPr>
@@ -120,22 +120,6 @@
       </a:defRPr>
     </a:lvl9pPr>
   </p:defaultTextStyle>
-  <p:extLst>
-    <p:ext uri="{EFAFB233-063F-42B5-8137-9DF3F51BA10A}">
-      <p15:sldGuideLst xmlns:p15="http://schemas.microsoft.com/office/powerpoint/2012/main">
-        <p15:guide id="1" orient="horz" pos="2160">
-          <p15:clr>
-            <a:srgbClr val="A4A3A4"/>
-          </p15:clr>
-        </p15:guide>
-        <p15:guide id="2" pos="2880">
-          <p15:clr>
-            <a:srgbClr val="A4A3A4"/>
-          </p15:clr>
-        </p15:guide>
-      </p15:sldGuideLst>
-    </p:ext>
-  </p:extLst>
 </p:presentation>
 </file>
 
@@ -177,9 +161,10 @@
           <a:lstStyle/>
           <a:p>
             <a:r>
-              <a:rPr lang="en-US"/>
+              <a:rPr lang="en-US" smtClean="0"/>
               <a:t>Click to edit Master title style</a:t>
             </a:r>
+            <a:endParaRPr lang="en-US"/>
           </a:p>
         </p:txBody>
       </p:sp>
@@ -295,9 +280,10 @@
           </a:lstStyle>
           <a:p>
             <a:r>
-              <a:rPr lang="en-US"/>
+              <a:rPr lang="en-US" smtClean="0"/>
               <a:t>Click to edit Master subtitle style</a:t>
             </a:r>
+            <a:endParaRPr lang="en-US"/>
           </a:p>
         </p:txBody>
       </p:sp>
@@ -318,7 +304,7 @@
           <a:p>
             <a:fld id="{5BCAD085-E8A6-8845-BD4E-CB4CCA059FC4}" type="datetimeFigureOut">
               <a:rPr lang="en-US" smtClean="0"/>
-              <a:t>6/14/2026</a:t>
+              <a:t>1/27/13</a:t>
             </a:fld>
             <a:endParaRPr lang="en-US"/>
           </a:p>
@@ -412,9 +398,10 @@
           <a:lstStyle/>
           <a:p>
             <a:r>
-              <a:rPr lang="en-US"/>
+              <a:rPr lang="en-US" smtClean="0"/>
               <a:t>Click to edit Master title style</a:t>
             </a:r>
+            <a:endParaRPr lang="en-US"/>
           </a:p>
         </p:txBody>
       </p:sp>
@@ -435,37 +422,38 @@
           <a:p>
             <a:pPr lvl="0"/>
             <a:r>
-              <a:rPr lang="en-US"/>
+              <a:rPr lang="en-US" smtClean="0"/>
               <a:t>Click to edit Master text styles</a:t>
             </a:r>
           </a:p>
           <a:p>
             <a:pPr lvl="1"/>
             <a:r>
-              <a:rPr lang="en-US"/>
+              <a:rPr lang="en-US" smtClean="0"/>
               <a:t>Second level</a:t>
             </a:r>
           </a:p>
           <a:p>
             <a:pPr lvl="2"/>
             <a:r>
-              <a:rPr lang="en-US"/>
+              <a:rPr lang="en-US" smtClean="0"/>
               <a:t>Third level</a:t>
             </a:r>
           </a:p>
           <a:p>
             <a:pPr lvl="3"/>
             <a:r>
-              <a:rPr lang="en-US"/>
+              <a:rPr lang="en-US" smtClean="0"/>
               <a:t>Fourth level</a:t>
             </a:r>
           </a:p>
           <a:p>
             <a:pPr lvl="4"/>
             <a:r>
-              <a:rPr lang="en-US"/>
+              <a:rPr lang="en-US" smtClean="0"/>
               <a:t>Fifth level</a:t>
             </a:r>
+            <a:endParaRPr lang="en-US"/>
           </a:p>
         </p:txBody>
       </p:sp>
@@ -486,7 +474,7 @@
           <a:p>
             <a:fld id="{5BCAD085-E8A6-8845-BD4E-CB4CCA059FC4}" type="datetimeFigureOut">
               <a:rPr lang="en-US" smtClean="0"/>
-              <a:t>6/14/2026</a:t>
+              <a:t>1/27/13</a:t>
             </a:fld>
             <a:endParaRPr lang="en-US"/>
           </a:p>
@@ -585,9 +573,10 @@
           <a:lstStyle/>
           <a:p>
             <a:r>
-              <a:rPr lang="en-US"/>
+              <a:rPr lang="en-US" smtClean="0"/>
               <a:t>Click to edit Master title style</a:t>
             </a:r>
+            <a:endParaRPr lang="en-US"/>
           </a:p>
         </p:txBody>
       </p:sp>
@@ -613,37 +602,38 @@
           <a:p>
             <a:pPr lvl="0"/>
             <a:r>
-              <a:rPr lang="en-US"/>
+              <a:rPr lang="en-US" smtClean="0"/>
               <a:t>Click to edit Master text styles</a:t>
             </a:r>
           </a:p>
           <a:p>
             <a:pPr lvl="1"/>
             <a:r>
-              <a:rPr lang="en-US"/>
+              <a:rPr lang="en-US" smtClean="0"/>
               <a:t>Second level</a:t>
             </a:r>
           </a:p>
           <a:p>
             <a:pPr lvl="2"/>
             <a:r>
-              <a:rPr lang="en-US"/>
+              <a:rPr lang="en-US" smtClean="0"/>
               <a:t>Third level</a:t>
             </a:r>
           </a:p>
           <a:p>
             <a:pPr lvl="3"/>
             <a:r>
-              <a:rPr lang="en-US"/>
+              <a:rPr lang="en-US" smtClean="0"/>
               <a:t>Fourth level</a:t>
             </a:r>
           </a:p>
           <a:p>
             <a:pPr lvl="4"/>
             <a:r>
-              <a:rPr lang="en-US"/>
+              <a:rPr lang="en-US" smtClean="0"/>
               <a:t>Fifth level</a:t>
             </a:r>
+            <a:endParaRPr lang="en-US"/>
           </a:p>
         </p:txBody>
       </p:sp>
@@ -664,7 +654,7 @@
           <a:p>
             <a:fld id="{5BCAD085-E8A6-8845-BD4E-CB4CCA059FC4}" type="datetimeFigureOut">
               <a:rPr lang="en-US" smtClean="0"/>
-              <a:t>6/14/2026</a:t>
+              <a:t>1/27/13</a:t>
             </a:fld>
             <a:endParaRPr lang="en-US"/>
           </a:p>
@@ -758,9 +748,10 @@
           <a:lstStyle/>
           <a:p>
             <a:r>
-              <a:rPr lang="en-US"/>
+              <a:rPr lang="en-US" smtClean="0"/>
               <a:t>Click to edit Master title style</a:t>
             </a:r>
+            <a:endParaRPr lang="en-US"/>
           </a:p>
         </p:txBody>
       </p:sp>
@@ -781,37 +772,38 @@
           <a:p>
             <a:pPr lvl="0"/>
             <a:r>
-              <a:rPr lang="en-US"/>
+              <a:rPr lang="en-US" smtClean="0"/>
               <a:t>Click to edit Master text styles</a:t>
             </a:r>
           </a:p>
           <a:p>
             <a:pPr lvl="1"/>
             <a:r>
-              <a:rPr lang="en-US"/>
+              <a:rPr lang="en-US" smtClean="0"/>
               <a:t>Second level</a:t>
             </a:r>
           </a:p>
           <a:p>
             <a:pPr lvl="2"/>
             <a:r>
-              <a:rPr lang="en-US"/>
+              <a:rPr lang="en-US" smtClean="0"/>
               <a:t>Third level</a:t>
             </a:r>
           </a:p>
           <a:p>
             <a:pPr lvl="3"/>
             <a:r>
-              <a:rPr lang="en-US"/>
+              <a:rPr lang="en-US" smtClean="0"/>
               <a:t>Fourth level</a:t>
             </a:r>
           </a:p>
           <a:p>
             <a:pPr lvl="4"/>
             <a:r>
-              <a:rPr lang="en-US"/>
+              <a:rPr lang="en-US" smtClean="0"/>
               <a:t>Fifth level</a:t>
             </a:r>
+            <a:endParaRPr lang="en-US"/>
           </a:p>
         </p:txBody>
       </p:sp>
@@ -832,7 +824,7 @@
           <a:p>
             <a:fld id="{5BCAD085-E8A6-8845-BD4E-CB4CCA059FC4}" type="datetimeFigureOut">
               <a:rPr lang="en-US" smtClean="0"/>
-              <a:t>6/14/2026</a:t>
+              <a:t>1/27/13</a:t>
             </a:fld>
             <a:endParaRPr lang="en-US"/>
           </a:p>
@@ -935,9 +927,10 @@
           </a:lstStyle>
           <a:p>
             <a:r>
-              <a:rPr lang="en-US"/>
+              <a:rPr lang="en-US" smtClean="0"/>
               <a:t>Click to edit Master title style</a:t>
             </a:r>
+            <a:endParaRPr lang="en-US"/>
           </a:p>
         </p:txBody>
       </p:sp>
@@ -1054,7 +1047,7 @@
           <a:p>
             <a:pPr lvl="0"/>
             <a:r>
-              <a:rPr lang="en-US"/>
+              <a:rPr lang="en-US" smtClean="0"/>
               <a:t>Click to edit Master text styles</a:t>
             </a:r>
           </a:p>
@@ -1077,7 +1070,7 @@
           <a:p>
             <a:fld id="{5BCAD085-E8A6-8845-BD4E-CB4CCA059FC4}" type="datetimeFigureOut">
               <a:rPr lang="en-US" smtClean="0"/>
-              <a:t>6/14/2026</a:t>
+              <a:t>1/27/13</a:t>
             </a:fld>
             <a:endParaRPr lang="en-US"/>
           </a:p>
@@ -1171,9 +1164,10 @@
           <a:lstStyle/>
           <a:p>
             <a:r>
-              <a:rPr lang="en-US"/>
+              <a:rPr lang="en-US" smtClean="0"/>
               <a:t>Click to edit Master title style</a:t>
             </a:r>
+            <a:endParaRPr lang="en-US"/>
           </a:p>
         </p:txBody>
       </p:sp>
@@ -1227,37 +1221,38 @@
           <a:p>
             <a:pPr lvl="0"/>
             <a:r>
-              <a:rPr lang="en-US"/>
+              <a:rPr lang="en-US" smtClean="0"/>
               <a:t>Click to edit Master text styles</a:t>
             </a:r>
           </a:p>
           <a:p>
             <a:pPr lvl="1"/>
             <a:r>
-              <a:rPr lang="en-US"/>
+              <a:rPr lang="en-US" smtClean="0"/>
               <a:t>Second level</a:t>
             </a:r>
           </a:p>
           <a:p>
             <a:pPr lvl="2"/>
             <a:r>
-              <a:rPr lang="en-US"/>
+              <a:rPr lang="en-US" smtClean="0"/>
               <a:t>Third level</a:t>
             </a:r>
           </a:p>
           <a:p>
             <a:pPr lvl="3"/>
             <a:r>
-              <a:rPr lang="en-US"/>
+              <a:rPr lang="en-US" smtClean="0"/>
               <a:t>Fourth level</a:t>
             </a:r>
           </a:p>
           <a:p>
             <a:pPr lvl="4"/>
             <a:r>
-              <a:rPr lang="en-US"/>
+              <a:rPr lang="en-US" smtClean="0"/>
               <a:t>Fifth level</a:t>
             </a:r>
+            <a:endParaRPr lang="en-US"/>
           </a:p>
         </p:txBody>
       </p:sp>
@@ -1311,37 +1306,38 @@
           <a:p>
             <a:pPr lvl="0"/>
             <a:r>
-              <a:rPr lang="en-US"/>
+              <a:rPr lang="en-US" smtClean="0"/>
               <a:t>Click to edit Master text styles</a:t>
             </a:r>
           </a:p>
           <a:p>
             <a:pPr lvl="1"/>
             <a:r>
-              <a:rPr lang="en-US"/>
+              <a:rPr lang="en-US" smtClean="0"/>
               <a:t>Second level</a:t>
             </a:r>
           </a:p>
           <a:p>
             <a:pPr lvl="2"/>
             <a:r>
-              <a:rPr lang="en-US"/>
+              <a:rPr lang="en-US" smtClean="0"/>
               <a:t>Third level</a:t>
             </a:r>
           </a:p>
           <a:p>
             <a:pPr lvl="3"/>
             <a:r>
-              <a:rPr lang="en-US"/>
+              <a:rPr lang="en-US" smtClean="0"/>
               <a:t>Fourth level</a:t>
             </a:r>
           </a:p>
           <a:p>
             <a:pPr lvl="4"/>
             <a:r>
-              <a:rPr lang="en-US"/>
+              <a:rPr lang="en-US" smtClean="0"/>
               <a:t>Fifth level</a:t>
             </a:r>
+            <a:endParaRPr lang="en-US"/>
           </a:p>
         </p:txBody>
       </p:sp>
@@ -1362,7 +1358,7 @@
           <a:p>
             <a:fld id="{5BCAD085-E8A6-8845-BD4E-CB4CCA059FC4}" type="datetimeFigureOut">
               <a:rPr lang="en-US" smtClean="0"/>
-              <a:t>6/14/2026</a:t>
+              <a:t>1/27/13</a:t>
             </a:fld>
             <a:endParaRPr lang="en-US"/>
           </a:p>
@@ -1460,9 +1456,10 @@
           </a:lstStyle>
           <a:p>
             <a:r>
-              <a:rPr lang="en-US"/>
+              <a:rPr lang="en-US" smtClean="0"/>
               <a:t>Click to edit Master title style</a:t>
             </a:r>
+            <a:endParaRPr lang="en-US"/>
           </a:p>
         </p:txBody>
       </p:sp>
@@ -1525,7 +1522,7 @@
           <a:p>
             <a:pPr lvl="0"/>
             <a:r>
-              <a:rPr lang="en-US"/>
+              <a:rPr lang="en-US" smtClean="0"/>
               <a:t>Click to edit Master text styles</a:t>
             </a:r>
           </a:p>
@@ -1581,37 +1578,38 @@
           <a:p>
             <a:pPr lvl="0"/>
             <a:r>
-              <a:rPr lang="en-US"/>
+              <a:rPr lang="en-US" smtClean="0"/>
               <a:t>Click to edit Master text styles</a:t>
             </a:r>
           </a:p>
           <a:p>
             <a:pPr lvl="1"/>
             <a:r>
-              <a:rPr lang="en-US"/>
+              <a:rPr lang="en-US" smtClean="0"/>
               <a:t>Second level</a:t>
             </a:r>
           </a:p>
           <a:p>
             <a:pPr lvl="2"/>
             <a:r>
-              <a:rPr lang="en-US"/>
+              <a:rPr lang="en-US" smtClean="0"/>
               <a:t>Third level</a:t>
             </a:r>
           </a:p>
           <a:p>
             <a:pPr lvl="3"/>
             <a:r>
-              <a:rPr lang="en-US"/>
+              <a:rPr lang="en-US" smtClean="0"/>
               <a:t>Fourth level</a:t>
             </a:r>
           </a:p>
           <a:p>
             <a:pPr lvl="4"/>
             <a:r>
-              <a:rPr lang="en-US"/>
+              <a:rPr lang="en-US" smtClean="0"/>
               <a:t>Fifth level</a:t>
             </a:r>
+            <a:endParaRPr lang="en-US"/>
           </a:p>
         </p:txBody>
       </p:sp>
@@ -1674,7 +1672,7 @@
           <a:p>
             <a:pPr lvl="0"/>
             <a:r>
-              <a:rPr lang="en-US"/>
+              <a:rPr lang="en-US" smtClean="0"/>
               <a:t>Click to edit Master text styles</a:t>
             </a:r>
           </a:p>
@@ -1730,37 +1728,38 @@
           <a:p>
             <a:pPr lvl="0"/>
             <a:r>
-              <a:rPr lang="en-US"/>
+              <a:rPr lang="en-US" smtClean="0"/>
               <a:t>Click to edit Master text styles</a:t>
             </a:r>
           </a:p>
           <a:p>
             <a:pPr lvl="1"/>
             <a:r>
-              <a:rPr lang="en-US"/>
+              <a:rPr lang="en-US" smtClean="0"/>
               <a:t>Second level</a:t>
             </a:r>
           </a:p>
           <a:p>
             <a:pPr lvl="2"/>
             <a:r>
-              <a:rPr lang="en-US"/>
+              <a:rPr lang="en-US" smtClean="0"/>
               <a:t>Third level</a:t>
             </a:r>
           </a:p>
           <a:p>
             <a:pPr lvl="3"/>
             <a:r>
-              <a:rPr lang="en-US"/>
+              <a:rPr lang="en-US" smtClean="0"/>
               <a:t>Fourth level</a:t>
             </a:r>
           </a:p>
           <a:p>
             <a:pPr lvl="4"/>
             <a:r>
-              <a:rPr lang="en-US"/>
+              <a:rPr lang="en-US" smtClean="0"/>
               <a:t>Fifth level</a:t>
             </a:r>
+            <a:endParaRPr lang="en-US"/>
           </a:p>
         </p:txBody>
       </p:sp>
@@ -1781,7 +1780,7 @@
           <a:p>
             <a:fld id="{5BCAD085-E8A6-8845-BD4E-CB4CCA059FC4}" type="datetimeFigureOut">
               <a:rPr lang="en-US" smtClean="0"/>
-              <a:t>6/14/2026</a:t>
+              <a:t>1/27/13</a:t>
             </a:fld>
             <a:endParaRPr lang="en-US"/>
           </a:p>
@@ -1875,9 +1874,10 @@
           <a:lstStyle/>
           <a:p>
             <a:r>
-              <a:rPr lang="en-US"/>
+              <a:rPr lang="en-US" smtClean="0"/>
               <a:t>Click to edit Master title style</a:t>
             </a:r>
+            <a:endParaRPr lang="en-US"/>
           </a:p>
         </p:txBody>
       </p:sp>
@@ -1898,7 +1898,7 @@
           <a:p>
             <a:fld id="{5BCAD085-E8A6-8845-BD4E-CB4CCA059FC4}" type="datetimeFigureOut">
               <a:rPr lang="en-US" smtClean="0"/>
-              <a:t>6/14/2026</a:t>
+              <a:t>1/27/13</a:t>
             </a:fld>
             <a:endParaRPr lang="en-US"/>
           </a:p>
@@ -1993,7 +1993,7 @@
           <a:p>
             <a:fld id="{5BCAD085-E8A6-8845-BD4E-CB4CCA059FC4}" type="datetimeFigureOut">
               <a:rPr lang="en-US" smtClean="0"/>
-              <a:t>6/14/2026</a:t>
+              <a:t>1/27/13</a:t>
             </a:fld>
             <a:endParaRPr lang="en-US"/>
           </a:p>
@@ -2096,9 +2096,10 @@
           </a:lstStyle>
           <a:p>
             <a:r>
-              <a:rPr lang="en-US"/>
+              <a:rPr lang="en-US" smtClean="0"/>
               <a:t>Click to edit Master title style</a:t>
             </a:r>
+            <a:endParaRPr lang="en-US"/>
           </a:p>
         </p:txBody>
       </p:sp>
@@ -2152,37 +2153,38 @@
           <a:p>
             <a:pPr lvl="0"/>
             <a:r>
-              <a:rPr lang="en-US"/>
+              <a:rPr lang="en-US" smtClean="0"/>
               <a:t>Click to edit Master text styles</a:t>
             </a:r>
           </a:p>
           <a:p>
             <a:pPr lvl="1"/>
             <a:r>
-              <a:rPr lang="en-US"/>
+              <a:rPr lang="en-US" smtClean="0"/>
               <a:t>Second level</a:t>
             </a:r>
           </a:p>
           <a:p>
             <a:pPr lvl="2"/>
             <a:r>
-              <a:rPr lang="en-US"/>
+              <a:rPr lang="en-US" smtClean="0"/>
               <a:t>Third level</a:t>
             </a:r>
           </a:p>
           <a:p>
             <a:pPr lvl="3"/>
             <a:r>
-              <a:rPr lang="en-US"/>
+              <a:rPr lang="en-US" smtClean="0"/>
               <a:t>Fourth level</a:t>
             </a:r>
           </a:p>
           <a:p>
             <a:pPr lvl="4"/>
             <a:r>
-              <a:rPr lang="en-US"/>
+              <a:rPr lang="en-US" smtClean="0"/>
               <a:t>Fifth level</a:t>
             </a:r>
+            <a:endParaRPr lang="en-US"/>
           </a:p>
         </p:txBody>
       </p:sp>
@@ -2245,7 +2247,7 @@
           <a:p>
             <a:pPr lvl="0"/>
             <a:r>
-              <a:rPr lang="en-US"/>
+              <a:rPr lang="en-US" smtClean="0"/>
               <a:t>Click to edit Master text styles</a:t>
             </a:r>
           </a:p>
@@ -2268,7 +2270,7 @@
           <a:p>
             <a:fld id="{5BCAD085-E8A6-8845-BD4E-CB4CCA059FC4}" type="datetimeFigureOut">
               <a:rPr lang="en-US" smtClean="0"/>
-              <a:t>6/14/2026</a:t>
+              <a:t>1/27/13</a:t>
             </a:fld>
             <a:endParaRPr lang="en-US"/>
           </a:p>
@@ -2371,9 +2373,10 @@
           </a:lstStyle>
           <a:p>
             <a:r>
-              <a:rPr lang="en-US"/>
+              <a:rPr lang="en-US" smtClean="0"/>
               <a:t>Click to edit Master title style</a:t>
             </a:r>
+            <a:endParaRPr lang="en-US"/>
           </a:p>
         </p:txBody>
       </p:sp>
@@ -2497,7 +2500,7 @@
           <a:p>
             <a:pPr lvl="0"/>
             <a:r>
-              <a:rPr lang="en-US"/>
+              <a:rPr lang="en-US" smtClean="0"/>
               <a:t>Click to edit Master text styles</a:t>
             </a:r>
           </a:p>
@@ -2520,7 +2523,7 @@
           <a:p>
             <a:fld id="{5BCAD085-E8A6-8845-BD4E-CB4CCA059FC4}" type="datetimeFigureOut">
               <a:rPr lang="en-US" smtClean="0"/>
-              <a:t>6/14/2026</a:t>
+              <a:t>1/27/13</a:t>
             </a:fld>
             <a:endParaRPr lang="en-US"/>
           </a:p>
@@ -2629,9 +2632,10 @@
           <a:lstStyle/>
           <a:p>
             <a:r>
-              <a:rPr lang="en-US"/>
+              <a:rPr lang="en-US" smtClean="0"/>
               <a:t>Click to edit Master title style</a:t>
             </a:r>
+            <a:endParaRPr lang="en-US"/>
           </a:p>
         </p:txBody>
       </p:sp>
@@ -2662,37 +2666,38 @@
           <a:p>
             <a:pPr lvl="0"/>
             <a:r>
-              <a:rPr lang="en-US"/>
+              <a:rPr lang="en-US" smtClean="0"/>
               <a:t>Click to edit Master text styles</a:t>
             </a:r>
           </a:p>
           <a:p>
             <a:pPr lvl="1"/>
             <a:r>
-              <a:rPr lang="en-US"/>
+              <a:rPr lang="en-US" smtClean="0"/>
               <a:t>Second level</a:t>
             </a:r>
           </a:p>
           <a:p>
             <a:pPr lvl="2"/>
             <a:r>
-              <a:rPr lang="en-US"/>
+              <a:rPr lang="en-US" smtClean="0"/>
               <a:t>Third level</a:t>
             </a:r>
           </a:p>
           <a:p>
             <a:pPr lvl="3"/>
             <a:r>
-              <a:rPr lang="en-US"/>
+              <a:rPr lang="en-US" smtClean="0"/>
               <a:t>Fourth level</a:t>
             </a:r>
           </a:p>
           <a:p>
             <a:pPr lvl="4"/>
             <a:r>
-              <a:rPr lang="en-US"/>
+              <a:rPr lang="en-US" smtClean="0"/>
               <a:t>Fifth level</a:t>
             </a:r>
+            <a:endParaRPr lang="en-US"/>
           </a:p>
         </p:txBody>
       </p:sp>
@@ -2731,7 +2736,7 @@
           <a:p>
             <a:fld id="{5BCAD085-E8A6-8845-BD4E-CB4CCA059FC4}" type="datetimeFigureOut">
               <a:rPr lang="en-US" smtClean="0"/>
-              <a:t>6/14/2026</a:t>
+              <a:t>1/27/13</a:t>
             </a:fld>
             <a:endParaRPr lang="en-US"/>
           </a:p>
@@ -3090,7 +3095,7 @@
 </file>
 
 <file path=ppt/slides/slide1.xml><?xml version="1.0" encoding="utf-8"?>
-<p:sld xmlns:a="http://schemas.openxmlformats.org/drawingml/2006/main" xmlns:r="http://schemas.openxmlformats.org/officeDocument/2006/relationships" xmlns:p="http://schemas.openxmlformats.org/presentationml/2006/main">
+<p:sld xmlns:a="http://schemas.openxmlformats.org/drawingml/2006/main" xmlns:p="http://schemas.openxmlformats.org/presentationml/2006/main" xmlns:r="http://schemas.openxmlformats.org/officeDocument/2006/relationships">
   <p:cSld>
     <p:bg>
       <p:bgPr>
@@ -3106,14 +3111,7 @@
         <p:cNvGrpSpPr/>
         <p:nvPr/>
       </p:nvGrpSpPr>
-      <p:grpSpPr>
-        <a:xfrm>
-          <a:off x="0" y="0"/>
-          <a:ext cx="0" cy="0"/>
-          <a:chOff x="0" y="0"/>
-          <a:chExt cx="0" cy="0"/>
-        </a:xfrm>
-      </p:grpSpPr>
+      <p:grpSpPr/>
       <p:sp>
         <p:nvSpPr>
           <p:cNvPr id="2" name="Rectangle 1"/>
@@ -3154,7 +3152,6 @@
           <a:lstStyle/>
           <a:p>
             <a:pPr algn="ctr"/>
-            <a:endParaRPr/>
           </a:p>
         </p:txBody>
       </p:sp>
@@ -3236,7 +3233,7 @@
 </file>
 
 <file path=ppt/slides/slide10.xml><?xml version="1.0" encoding="utf-8"?>
-<p:sld xmlns:a="http://schemas.openxmlformats.org/drawingml/2006/main" xmlns:r="http://schemas.openxmlformats.org/officeDocument/2006/relationships" xmlns:p="http://schemas.openxmlformats.org/presentationml/2006/main">
+<p:sld xmlns:a="http://schemas.openxmlformats.org/drawingml/2006/main" xmlns:p="http://schemas.openxmlformats.org/presentationml/2006/main" xmlns:r="http://schemas.openxmlformats.org/officeDocument/2006/relationships">
   <p:cSld>
     <p:bg>
       <p:bgPr>
@@ -3252,14 +3249,7 @@
         <p:cNvGrpSpPr/>
         <p:nvPr/>
       </p:nvGrpSpPr>
-      <p:grpSpPr>
-        <a:xfrm>
-          <a:off x="0" y="0"/>
-          <a:ext cx="0" cy="0"/>
-          <a:chOff x="0" y="0"/>
-          <a:chExt cx="0" cy="0"/>
-        </a:xfrm>
-      </p:grpSpPr>
+      <p:grpSpPr/>
       <p:sp>
         <p:nvSpPr>
           <p:cNvPr id="2" name="TextBox 1"/>
@@ -3335,7 +3325,6 @@
           <a:lstStyle/>
           <a:p>
             <a:pPr algn="ctr"/>
-            <a:endParaRPr/>
           </a:p>
         </p:txBody>
       </p:sp>
@@ -3403,7 +3392,6 @@
                 </a:solidFill>
               </a:defRPr>
             </a:pPr>
-            <a:endParaRPr/>
           </a:p>
         </p:txBody>
       </p:sp>
@@ -3447,7 +3435,6 @@
           <a:lstStyle/>
           <a:p>
             <a:pPr algn="ctr"/>
-            <a:endParaRPr/>
           </a:p>
         </p:txBody>
       </p:sp>
@@ -3505,20 +3492,8 @@
                 <a:tableStyleId>{5C22544A-7EE6-4342-B048-85BDC9FD1C3A}</a:tableStyleId>
               </a:tblPr>
               <a:tblGrid>
-                <a:gridCol w="5623560">
-                  <a:extLst>
-                    <a:ext uri="{9D8B030D-6E8A-4147-A177-3AD203B41FA5}">
-                      <a16:colId xmlns:a16="http://schemas.microsoft.com/office/drawing/2014/main" val="20000"/>
-                    </a:ext>
-                  </a:extLst>
-                </a:gridCol>
-                <a:gridCol w="5623560">
-                  <a:extLst>
-                    <a:ext uri="{9D8B030D-6E8A-4147-A177-3AD203B41FA5}">
-                      <a16:colId xmlns:a16="http://schemas.microsoft.com/office/drawing/2014/main" val="20001"/>
-                    </a:ext>
-                  </a:extLst>
-                </a:gridCol>
+                <a:gridCol w="5623560"/>
+                <a:gridCol w="5623560"/>
               </a:tblGrid>
               <a:tr h="384048">
                 <a:tc>
@@ -3527,7 +3502,7 @@
                     <a:lstStyle/>
                     <a:p>
                       <a:pPr>
-                        <a:defRPr sz="1000" b="1">
+                        <a:defRPr b="1" sz="1000">
                           <a:solidFill>
                             <a:srgbClr val="FFFFFF"/>
                           </a:solidFill>
@@ -3550,7 +3525,7 @@
                     <a:lstStyle/>
                     <a:p>
                       <a:pPr>
-                        <a:defRPr sz="1000" b="1">
+                        <a:defRPr b="1" sz="1000">
                           <a:solidFill>
                             <a:srgbClr val="FFFFFF"/>
                           </a:solidFill>
@@ -3567,11 +3542,6 @@
                     </a:solidFill>
                   </a:tcPr>
                 </a:tc>
-                <a:extLst>
-                  <a:ext uri="{0D108BD9-81ED-4DB2-BD59-A6C34878D82A}">
-                    <a16:rowId xmlns:a16="http://schemas.microsoft.com/office/drawing/2014/main" val="10000"/>
-                  </a:ext>
-                </a:extLst>
               </a:tr>
               <a:tr h="384048">
                 <a:tc>
@@ -3604,11 +3574,6 @@
                   </a:txBody>
                   <a:tcPr/>
                 </a:tc>
-                <a:extLst>
-                  <a:ext uri="{0D108BD9-81ED-4DB2-BD59-A6C34878D82A}">
-                    <a16:rowId xmlns:a16="http://schemas.microsoft.com/office/drawing/2014/main" val="10001"/>
-                  </a:ext>
-                </a:extLst>
               </a:tr>
               <a:tr h="384048">
                 <a:tc>
@@ -3641,11 +3606,6 @@
                   </a:txBody>
                   <a:tcPr/>
                 </a:tc>
-                <a:extLst>
-                  <a:ext uri="{0D108BD9-81ED-4DB2-BD59-A6C34878D82A}">
-                    <a16:rowId xmlns:a16="http://schemas.microsoft.com/office/drawing/2014/main" val="10002"/>
-                  </a:ext>
-                </a:extLst>
               </a:tr>
               <a:tr h="384048">
                 <a:tc>
@@ -3678,11 +3638,6 @@
                   </a:txBody>
                   <a:tcPr/>
                 </a:tc>
-                <a:extLst>
-                  <a:ext uri="{0D108BD9-81ED-4DB2-BD59-A6C34878D82A}">
-                    <a16:rowId xmlns:a16="http://schemas.microsoft.com/office/drawing/2014/main" val="10003"/>
-                  </a:ext>
-                </a:extLst>
               </a:tr>
               <a:tr h="384048">
                 <a:tc>
@@ -3715,11 +3670,6 @@
                   </a:txBody>
                   <a:tcPr/>
                 </a:tc>
-                <a:extLst>
-                  <a:ext uri="{0D108BD9-81ED-4DB2-BD59-A6C34878D82A}">
-                    <a16:rowId xmlns:a16="http://schemas.microsoft.com/office/drawing/2014/main" val="10004"/>
-                  </a:ext>
-                </a:extLst>
               </a:tr>
               <a:tr h="384048">
                 <a:tc>
@@ -3752,11 +3702,6 @@
                   </a:txBody>
                   <a:tcPr/>
                 </a:tc>
-                <a:extLst>
-                  <a:ext uri="{0D108BD9-81ED-4DB2-BD59-A6C34878D82A}">
-                    <a16:rowId xmlns:a16="http://schemas.microsoft.com/office/drawing/2014/main" val="10005"/>
-                  </a:ext>
-                </a:extLst>
               </a:tr>
               <a:tr h="384048">
                 <a:tc>
@@ -3789,11 +3734,6 @@
                   </a:txBody>
                   <a:tcPr/>
                 </a:tc>
-                <a:extLst>
-                  <a:ext uri="{0D108BD9-81ED-4DB2-BD59-A6C34878D82A}">
-                    <a16:rowId xmlns:a16="http://schemas.microsoft.com/office/drawing/2014/main" val="10006"/>
-                  </a:ext>
-                </a:extLst>
               </a:tr>
               <a:tr h="384048">
                 <a:tc>
@@ -3826,11 +3766,6 @@
                   </a:txBody>
                   <a:tcPr/>
                 </a:tc>
-                <a:extLst>
-                  <a:ext uri="{0D108BD9-81ED-4DB2-BD59-A6C34878D82A}">
-                    <a16:rowId xmlns:a16="http://schemas.microsoft.com/office/drawing/2014/main" val="10007"/>
-                  </a:ext>
-                </a:extLst>
               </a:tr>
             </a:tbl>
           </a:graphicData>
@@ -3845,7 +3780,7 @@
 </file>
 
 <file path=ppt/slides/slide11.xml><?xml version="1.0" encoding="utf-8"?>
-<p:sld xmlns:a="http://schemas.openxmlformats.org/drawingml/2006/main" xmlns:r="http://schemas.openxmlformats.org/officeDocument/2006/relationships" xmlns:p="http://schemas.openxmlformats.org/presentationml/2006/main">
+<p:sld xmlns:a="http://schemas.openxmlformats.org/drawingml/2006/main" xmlns:p="http://schemas.openxmlformats.org/presentationml/2006/main" xmlns:r="http://schemas.openxmlformats.org/officeDocument/2006/relationships">
   <p:cSld>
     <p:bg>
       <p:bgPr>
@@ -3861,14 +3796,7 @@
         <p:cNvGrpSpPr/>
         <p:nvPr/>
       </p:nvGrpSpPr>
-      <p:grpSpPr>
-        <a:xfrm>
-          <a:off x="0" y="0"/>
-          <a:ext cx="0" cy="0"/>
-          <a:chOff x="0" y="0"/>
-          <a:chExt cx="0" cy="0"/>
-        </a:xfrm>
-      </p:grpSpPr>
+      <p:grpSpPr/>
       <p:sp>
         <p:nvSpPr>
           <p:cNvPr id="2" name="TextBox 1"/>
@@ -3944,7 +3872,6 @@
           <a:lstStyle/>
           <a:p>
             <a:pPr algn="ctr"/>
-            <a:endParaRPr/>
           </a:p>
         </p:txBody>
       </p:sp>
@@ -4002,41 +3929,11 @@
                 <a:tableStyleId>{5C22544A-7EE6-4342-B048-85BDC9FD1C3A}</a:tableStyleId>
               </a:tblPr>
               <a:tblGrid>
-                <a:gridCol w="2249424">
-                  <a:extLst>
-                    <a:ext uri="{9D8B030D-6E8A-4147-A177-3AD203B41FA5}">
-                      <a16:colId xmlns:a16="http://schemas.microsoft.com/office/drawing/2014/main" val="20000"/>
-                    </a:ext>
-                  </a:extLst>
-                </a:gridCol>
-                <a:gridCol w="2249424">
-                  <a:extLst>
-                    <a:ext uri="{9D8B030D-6E8A-4147-A177-3AD203B41FA5}">
-                      <a16:colId xmlns:a16="http://schemas.microsoft.com/office/drawing/2014/main" val="20001"/>
-                    </a:ext>
-                  </a:extLst>
-                </a:gridCol>
-                <a:gridCol w="2249424">
-                  <a:extLst>
-                    <a:ext uri="{9D8B030D-6E8A-4147-A177-3AD203B41FA5}">
-                      <a16:colId xmlns:a16="http://schemas.microsoft.com/office/drawing/2014/main" val="20002"/>
-                    </a:ext>
-                  </a:extLst>
-                </a:gridCol>
-                <a:gridCol w="2249424">
-                  <a:extLst>
-                    <a:ext uri="{9D8B030D-6E8A-4147-A177-3AD203B41FA5}">
-                      <a16:colId xmlns:a16="http://schemas.microsoft.com/office/drawing/2014/main" val="20003"/>
-                    </a:ext>
-                  </a:extLst>
-                </a:gridCol>
-                <a:gridCol w="2249424">
-                  <a:extLst>
-                    <a:ext uri="{9D8B030D-6E8A-4147-A177-3AD203B41FA5}">
-                      <a16:colId xmlns:a16="http://schemas.microsoft.com/office/drawing/2014/main" val="20004"/>
-                    </a:ext>
-                  </a:extLst>
-                </a:gridCol>
+                <a:gridCol w="2249424"/>
+                <a:gridCol w="2249424"/>
+                <a:gridCol w="2249424"/>
+                <a:gridCol w="2249424"/>
+                <a:gridCol w="2249424"/>
               </a:tblGrid>
               <a:tr h="384048">
                 <a:tc>
@@ -4045,7 +3942,7 @@
                     <a:lstStyle/>
                     <a:p>
                       <a:pPr>
-                        <a:defRPr sz="1000" b="1">
+                        <a:defRPr b="1" sz="1000">
                           <a:solidFill>
                             <a:srgbClr val="FFFFFF"/>
                           </a:solidFill>
@@ -4068,7 +3965,7 @@
                     <a:lstStyle/>
                     <a:p>
                       <a:pPr>
-                        <a:defRPr sz="1000" b="1">
+                        <a:defRPr b="1" sz="1000">
                           <a:solidFill>
                             <a:srgbClr val="FFFFFF"/>
                           </a:solidFill>
@@ -4091,7 +3988,7 @@
                     <a:lstStyle/>
                     <a:p>
                       <a:pPr>
-                        <a:defRPr sz="1000" b="1">
+                        <a:defRPr b="1" sz="1000">
                           <a:solidFill>
                             <a:srgbClr val="FFFFFF"/>
                           </a:solidFill>
@@ -4114,7 +4011,7 @@
                     <a:lstStyle/>
                     <a:p>
                       <a:pPr>
-                        <a:defRPr sz="1000" b="1">
+                        <a:defRPr b="1" sz="1000">
                           <a:solidFill>
                             <a:srgbClr val="FFFFFF"/>
                           </a:solidFill>
@@ -4137,7 +4034,7 @@
                     <a:lstStyle/>
                     <a:p>
                       <a:pPr>
-                        <a:defRPr sz="1000" b="1">
+                        <a:defRPr b="1" sz="1000">
                           <a:solidFill>
                             <a:srgbClr val="FFFFFF"/>
                           </a:solidFill>
@@ -4154,11 +4051,6 @@
                     </a:solidFill>
                   </a:tcPr>
                 </a:tc>
-                <a:extLst>
-                  <a:ext uri="{0D108BD9-81ED-4DB2-BD59-A6C34878D82A}">
-                    <a16:rowId xmlns:a16="http://schemas.microsoft.com/office/drawing/2014/main" val="10000"/>
-                  </a:ext>
-                </a:extLst>
               </a:tr>
               <a:tr h="384048">
                 <a:tc>
@@ -4236,11 +4128,6 @@
                   </a:txBody>
                   <a:tcPr/>
                 </a:tc>
-                <a:extLst>
-                  <a:ext uri="{0D108BD9-81ED-4DB2-BD59-A6C34878D82A}">
-                    <a16:rowId xmlns:a16="http://schemas.microsoft.com/office/drawing/2014/main" val="10001"/>
-                  </a:ext>
-                </a:extLst>
               </a:tr>
               <a:tr h="384048">
                 <a:tc>
@@ -4318,11 +4205,6 @@
                   </a:txBody>
                   <a:tcPr/>
                 </a:tc>
-                <a:extLst>
-                  <a:ext uri="{0D108BD9-81ED-4DB2-BD59-A6C34878D82A}">
-                    <a16:rowId xmlns:a16="http://schemas.microsoft.com/office/drawing/2014/main" val="10002"/>
-                  </a:ext>
-                </a:extLst>
               </a:tr>
               <a:tr h="384048">
                 <a:tc>
@@ -4400,11 +4282,6 @@
                   </a:txBody>
                   <a:tcPr/>
                 </a:tc>
-                <a:extLst>
-                  <a:ext uri="{0D108BD9-81ED-4DB2-BD59-A6C34878D82A}">
-                    <a16:rowId xmlns:a16="http://schemas.microsoft.com/office/drawing/2014/main" val="10003"/>
-                  </a:ext>
-                </a:extLst>
               </a:tr>
             </a:tbl>
           </a:graphicData>
@@ -4419,7 +4296,7 @@
 </file>
 
 <file path=ppt/slides/slide12.xml><?xml version="1.0" encoding="utf-8"?>
-<p:sld xmlns:a="http://schemas.openxmlformats.org/drawingml/2006/main" xmlns:r="http://schemas.openxmlformats.org/officeDocument/2006/relationships" xmlns:p="http://schemas.openxmlformats.org/presentationml/2006/main">
+<p:sld xmlns:a="http://schemas.openxmlformats.org/drawingml/2006/main" xmlns:p="http://schemas.openxmlformats.org/presentationml/2006/main" xmlns:r="http://schemas.openxmlformats.org/officeDocument/2006/relationships">
   <p:cSld>
     <p:bg>
       <p:bgPr>
@@ -4435,14 +4312,7 @@
         <p:cNvGrpSpPr/>
         <p:nvPr/>
       </p:nvGrpSpPr>
-      <p:grpSpPr>
-        <a:xfrm>
-          <a:off x="0" y="0"/>
-          <a:ext cx="0" cy="0"/>
-          <a:chOff x="0" y="0"/>
-          <a:chExt cx="0" cy="0"/>
-        </a:xfrm>
-      </p:grpSpPr>
+      <p:grpSpPr/>
       <p:sp>
         <p:nvSpPr>
           <p:cNvPr id="2" name="TextBox 1"/>
@@ -4518,7 +4388,6 @@
           <a:lstStyle/>
           <a:p>
             <a:pPr algn="ctr"/>
-            <a:endParaRPr/>
           </a:p>
         </p:txBody>
       </p:sp>
@@ -4576,41 +4445,11 @@
                 <a:tableStyleId>{5C22544A-7EE6-4342-B048-85BDC9FD1C3A}</a:tableStyleId>
               </a:tblPr>
               <a:tblGrid>
-                <a:gridCol w="2249424">
-                  <a:extLst>
-                    <a:ext uri="{9D8B030D-6E8A-4147-A177-3AD203B41FA5}">
-                      <a16:colId xmlns:a16="http://schemas.microsoft.com/office/drawing/2014/main" val="20000"/>
-                    </a:ext>
-                  </a:extLst>
-                </a:gridCol>
-                <a:gridCol w="2249424">
-                  <a:extLst>
-                    <a:ext uri="{9D8B030D-6E8A-4147-A177-3AD203B41FA5}">
-                      <a16:colId xmlns:a16="http://schemas.microsoft.com/office/drawing/2014/main" val="20001"/>
-                    </a:ext>
-                  </a:extLst>
-                </a:gridCol>
-                <a:gridCol w="2249424">
-                  <a:extLst>
-                    <a:ext uri="{9D8B030D-6E8A-4147-A177-3AD203B41FA5}">
-                      <a16:colId xmlns:a16="http://schemas.microsoft.com/office/drawing/2014/main" val="20002"/>
-                    </a:ext>
-                  </a:extLst>
-                </a:gridCol>
-                <a:gridCol w="2249424">
-                  <a:extLst>
-                    <a:ext uri="{9D8B030D-6E8A-4147-A177-3AD203B41FA5}">
-                      <a16:colId xmlns:a16="http://schemas.microsoft.com/office/drawing/2014/main" val="20003"/>
-                    </a:ext>
-                  </a:extLst>
-                </a:gridCol>
-                <a:gridCol w="2249424">
-                  <a:extLst>
-                    <a:ext uri="{9D8B030D-6E8A-4147-A177-3AD203B41FA5}">
-                      <a16:colId xmlns:a16="http://schemas.microsoft.com/office/drawing/2014/main" val="20004"/>
-                    </a:ext>
-                  </a:extLst>
-                </a:gridCol>
+                <a:gridCol w="2249424"/>
+                <a:gridCol w="2249424"/>
+                <a:gridCol w="2249424"/>
+                <a:gridCol w="2249424"/>
+                <a:gridCol w="2249424"/>
               </a:tblGrid>
               <a:tr h="384048">
                 <a:tc>
@@ -4619,7 +4458,7 @@
                     <a:lstStyle/>
                     <a:p>
                       <a:pPr>
-                        <a:defRPr sz="1000" b="1">
+                        <a:defRPr b="1" sz="1000">
                           <a:solidFill>
                             <a:srgbClr val="FFFFFF"/>
                           </a:solidFill>
@@ -4642,7 +4481,7 @@
                     <a:lstStyle/>
                     <a:p>
                       <a:pPr>
-                        <a:defRPr sz="1000" b="1">
+                        <a:defRPr b="1" sz="1000">
                           <a:solidFill>
                             <a:srgbClr val="FFFFFF"/>
                           </a:solidFill>
@@ -4665,7 +4504,7 @@
                     <a:lstStyle/>
                     <a:p>
                       <a:pPr>
-                        <a:defRPr sz="1000" b="1">
+                        <a:defRPr b="1" sz="1000">
                           <a:solidFill>
                             <a:srgbClr val="FFFFFF"/>
                           </a:solidFill>
@@ -4688,7 +4527,7 @@
                     <a:lstStyle/>
                     <a:p>
                       <a:pPr>
-                        <a:defRPr sz="1000" b="1">
+                        <a:defRPr b="1" sz="1000">
                           <a:solidFill>
                             <a:srgbClr val="FFFFFF"/>
                           </a:solidFill>
@@ -4711,7 +4550,7 @@
                     <a:lstStyle/>
                     <a:p>
                       <a:pPr>
-                        <a:defRPr sz="1000" b="1">
+                        <a:defRPr b="1" sz="1000">
                           <a:solidFill>
                             <a:srgbClr val="FFFFFF"/>
                           </a:solidFill>
@@ -4728,11 +4567,6 @@
                     </a:solidFill>
                   </a:tcPr>
                 </a:tc>
-                <a:extLst>
-                  <a:ext uri="{0D108BD9-81ED-4DB2-BD59-A6C34878D82A}">
-                    <a16:rowId xmlns:a16="http://schemas.microsoft.com/office/drawing/2014/main" val="10000"/>
-                  </a:ext>
-                </a:extLst>
               </a:tr>
               <a:tr h="384048">
                 <a:tc>
@@ -4759,7 +4593,7 @@
                         <a:defRPr sz="900"/>
                       </a:pPr>
                       <a:r>
-                        <a:t>1.6467</a:t>
+                        <a:t>1.6683</a:t>
                       </a:r>
                     </a:p>
                   </a:txBody>
@@ -4774,7 +4608,7 @@
                         <a:defRPr sz="900"/>
                       </a:pPr>
                       <a:r>
-                        <a:t>1.4141</a:t>
+                        <a:t>1.4244</a:t>
                       </a:r>
                     </a:p>
                   </a:txBody>
@@ -4789,7 +4623,7 @@
                         <a:defRPr sz="900"/>
                       </a:pPr>
                       <a:r>
-                        <a:t>37.72%</a:t>
+                        <a:t>38.71%</a:t>
                       </a:r>
                     </a:p>
                   </a:txBody>
@@ -4804,17 +4638,12 @@
                         <a:defRPr sz="900"/>
                       </a:pPr>
                       <a:r>
-                        <a:t>57.47%</a:t>
+                        <a:t>60.92%</a:t>
                       </a:r>
                     </a:p>
                   </a:txBody>
                   <a:tcPr/>
                 </a:tc>
-                <a:extLst>
-                  <a:ext uri="{0D108BD9-81ED-4DB2-BD59-A6C34878D82A}">
-                    <a16:rowId xmlns:a16="http://schemas.microsoft.com/office/drawing/2014/main" val="10001"/>
-                  </a:ext>
-                </a:extLst>
               </a:tr>
               <a:tr h="384048">
                 <a:tc>
@@ -4841,7 +4670,7 @@
                         <a:defRPr sz="900"/>
                       </a:pPr>
                       <a:r>
-                        <a:t>1.5898</a:t>
+                        <a:t>1.5942</a:t>
                       </a:r>
                     </a:p>
                   </a:txBody>
@@ -4856,7 +4685,7 @@
                         <a:defRPr sz="900"/>
                       </a:pPr>
                       <a:r>
-                        <a:t>1.3763</a:t>
+                        <a:t>1.3822</a:t>
                       </a:r>
                     </a:p>
                   </a:txBody>
@@ -4871,7 +4700,7 @@
                         <a:defRPr sz="900"/>
                       </a:pPr>
                       <a:r>
-                        <a:t>35.54%</a:t>
+                        <a:t>39.60%</a:t>
                       </a:r>
                     </a:p>
                   </a:txBody>
@@ -4886,17 +4715,12 @@
                         <a:defRPr sz="900"/>
                       </a:pPr>
                       <a:r>
-                        <a:t>62.30%</a:t>
+                        <a:t>59.78%</a:t>
                       </a:r>
                     </a:p>
                   </a:txBody>
                   <a:tcPr/>
                 </a:tc>
-                <a:extLst>
-                  <a:ext uri="{0D108BD9-81ED-4DB2-BD59-A6C34878D82A}">
-                    <a16:rowId xmlns:a16="http://schemas.microsoft.com/office/drawing/2014/main" val="10002"/>
-                  </a:ext>
-                </a:extLst>
               </a:tr>
             </a:tbl>
           </a:graphicData>
@@ -4911,7 +4735,7 @@
 </file>
 
 <file path=ppt/slides/slide13.xml><?xml version="1.0" encoding="utf-8"?>
-<p:sld xmlns:a="http://schemas.openxmlformats.org/drawingml/2006/main" xmlns:r="http://schemas.openxmlformats.org/officeDocument/2006/relationships" xmlns:p="http://schemas.openxmlformats.org/presentationml/2006/main">
+<p:sld xmlns:a="http://schemas.openxmlformats.org/drawingml/2006/main" xmlns:p="http://schemas.openxmlformats.org/presentationml/2006/main" xmlns:r="http://schemas.openxmlformats.org/officeDocument/2006/relationships">
   <p:cSld>
     <p:bg>
       <p:bgPr>
@@ -4927,14 +4751,7 @@
         <p:cNvGrpSpPr/>
         <p:nvPr/>
       </p:nvGrpSpPr>
-      <p:grpSpPr>
-        <a:xfrm>
-          <a:off x="0" y="0"/>
-          <a:ext cx="0" cy="0"/>
-          <a:chOff x="0" y="0"/>
-          <a:chExt cx="0" cy="0"/>
-        </a:xfrm>
-      </p:grpSpPr>
+      <p:grpSpPr/>
       <p:sp>
         <p:nvSpPr>
           <p:cNvPr id="2" name="TextBox 1"/>
@@ -5010,7 +4827,6 @@
           <a:lstStyle/>
           <a:p>
             <a:pPr algn="ctr"/>
-            <a:endParaRPr/>
           </a:p>
         </p:txBody>
       </p:sp>
@@ -5106,7 +4922,7 @@
 </file>
 
 <file path=ppt/slides/slide14.xml><?xml version="1.0" encoding="utf-8"?>
-<p:sld xmlns:a="http://schemas.openxmlformats.org/drawingml/2006/main" xmlns:r="http://schemas.openxmlformats.org/officeDocument/2006/relationships" xmlns:p="http://schemas.openxmlformats.org/presentationml/2006/main">
+<p:sld xmlns:a="http://schemas.openxmlformats.org/drawingml/2006/main" xmlns:p="http://schemas.openxmlformats.org/presentationml/2006/main" xmlns:r="http://schemas.openxmlformats.org/officeDocument/2006/relationships">
   <p:cSld>
     <p:bg>
       <p:bgPr>
@@ -5122,14 +4938,7 @@
         <p:cNvGrpSpPr/>
         <p:nvPr/>
       </p:nvGrpSpPr>
-      <p:grpSpPr>
-        <a:xfrm>
-          <a:off x="0" y="0"/>
-          <a:ext cx="0" cy="0"/>
-          <a:chOff x="0" y="0"/>
-          <a:chExt cx="0" cy="0"/>
-        </a:xfrm>
-      </p:grpSpPr>
+      <p:grpSpPr/>
       <p:sp>
         <p:nvSpPr>
           <p:cNvPr id="2" name="TextBox 1"/>
@@ -5205,7 +5014,6 @@
           <a:lstStyle/>
           <a:p>
             <a:pPr algn="ctr"/>
-            <a:endParaRPr/>
           </a:p>
         </p:txBody>
       </p:sp>
@@ -5292,7 +5100,7 @@
               </a:defRPr>
             </a:pPr>
             <a:r>
-              <a:t>• Rating Prediction → NCF (RMSE=1.5898)</a:t>
+              <a:t>• Rating Prediction → NCF (RMSE=1.5942)</a:t>
             </a:r>
           </a:p>
           <a:p>
@@ -5307,7 +5115,7 @@
               </a:defRPr>
             </a:pPr>
             <a:r>
-              <a:t>• Top-K Ranking → User-CF Cosine (P@10=39.50%)</a:t>
+              <a:t>• Top-K Ranking → NCF (P@10=39.60%) &amp; User-CF (P@10=39.50%)</a:t>
             </a:r>
           </a:p>
           <a:p>
@@ -5322,7 +5130,7 @@
               </a:defRPr>
             </a:pPr>
             <a:r>
-              <a:t>• MRR cao nhất → NCF (62.30%)</a:t>
+              <a:t>• MRR tốt nhất → Funk SVD (MRR=60.92%)</a:t>
             </a:r>
           </a:p>
           <a:p>
@@ -5390,7 +5198,7 @@
               </a:defRPr>
             </a:pPr>
             <a:r>
-              <a:t>📊 P@10 chênh 35.5%–39.5% (tối đa 4 điểm %)</a:t>
+              <a:t>📊 P@10 chênh lệch giữa các mô hình nhỏ (~1-3%)</a:t>
             </a:r>
           </a:p>
           <a:p>
@@ -5405,7 +5213,7 @@
               </a:defRPr>
             </a:pPr>
             <a:r>
-              <a:t>📊 Optimize regression ≠ optimize ranking</a:t>
+              <a:t>📊 Tối ưu hóa RMSE không đồng nghĩa tối ưu hóa Precision@10</a:t>
             </a:r>
           </a:p>
           <a:p>
@@ -5420,7 +5228,7 @@
               </a:defRPr>
             </a:pPr>
             <a:r>
-              <a:t>📊 CF &gt; CBF vì khai thác trực tiếp hành vi MXH</a:t>
+              <a:t>📊 Học máy phi tuyến (NCF) mạnh về dự đoán điểm tương tác</a:t>
             </a:r>
           </a:p>
           <a:p>
@@ -5435,7 +5243,7 @@
               </a:defRPr>
             </a:pPr>
             <a:r>
-              <a:t>📊 NCF thắng RMSE nhưng thua P@10 → trade-off</a:t>
+              <a:t>📊 Học sâu &amp; Phân rã ma trận tối ưu tùy theo mục tiêu cụ thể</a:t>
             </a:r>
           </a:p>
         </p:txBody>
@@ -5449,7 +5257,7 @@
 </file>
 
 <file path=ppt/slides/slide15.xml><?xml version="1.0" encoding="utf-8"?>
-<p:sld xmlns:a="http://schemas.openxmlformats.org/drawingml/2006/main" xmlns:r="http://schemas.openxmlformats.org/officeDocument/2006/relationships" xmlns:p="http://schemas.openxmlformats.org/presentationml/2006/main">
+<p:sld xmlns:a="http://schemas.openxmlformats.org/drawingml/2006/main" xmlns:p="http://schemas.openxmlformats.org/presentationml/2006/main" xmlns:r="http://schemas.openxmlformats.org/officeDocument/2006/relationships">
   <p:cSld>
     <p:bg>
       <p:bgPr>
@@ -5465,14 +5273,7 @@
         <p:cNvGrpSpPr/>
         <p:nvPr/>
       </p:nvGrpSpPr>
-      <p:grpSpPr>
-        <a:xfrm>
-          <a:off x="0" y="0"/>
-          <a:ext cx="0" cy="0"/>
-          <a:chOff x="0" y="0"/>
-          <a:chExt cx="0" cy="0"/>
-        </a:xfrm>
-      </p:grpSpPr>
+      <p:grpSpPr/>
       <p:sp>
         <p:nvSpPr>
           <p:cNvPr id="2" name="TextBox 1"/>
@@ -5548,7 +5349,6 @@
           <a:lstStyle/>
           <a:p>
             <a:pPr algn="ctr"/>
-            <a:endParaRPr/>
           </a:p>
         </p:txBody>
       </p:sp>
@@ -5616,7 +5416,6 @@
                 </a:solidFill>
               </a:defRPr>
             </a:pPr>
-            <a:endParaRPr/>
           </a:p>
         </p:txBody>
       </p:sp>
@@ -5660,7 +5459,6 @@
           <a:lstStyle/>
           <a:p>
             <a:pPr algn="ctr"/>
-            <a:endParaRPr/>
           </a:p>
         </p:txBody>
       </p:sp>
@@ -5718,27 +5516,9 @@
                 <a:tableStyleId>{5C22544A-7EE6-4342-B048-85BDC9FD1C3A}</a:tableStyleId>
               </a:tblPr>
               <a:tblGrid>
-                <a:gridCol w="3749040">
-                  <a:extLst>
-                    <a:ext uri="{9D8B030D-6E8A-4147-A177-3AD203B41FA5}">
-                      <a16:colId xmlns:a16="http://schemas.microsoft.com/office/drawing/2014/main" val="20000"/>
-                    </a:ext>
-                  </a:extLst>
-                </a:gridCol>
-                <a:gridCol w="3749040">
-                  <a:extLst>
-                    <a:ext uri="{9D8B030D-6E8A-4147-A177-3AD203B41FA5}">
-                      <a16:colId xmlns:a16="http://schemas.microsoft.com/office/drawing/2014/main" val="20001"/>
-                    </a:ext>
-                  </a:extLst>
-                </a:gridCol>
-                <a:gridCol w="3749040">
-                  <a:extLst>
-                    <a:ext uri="{9D8B030D-6E8A-4147-A177-3AD203B41FA5}">
-                      <a16:colId xmlns:a16="http://schemas.microsoft.com/office/drawing/2014/main" val="20002"/>
-                    </a:ext>
-                  </a:extLst>
-                </a:gridCol>
+                <a:gridCol w="3749040"/>
+                <a:gridCol w="3749040"/>
+                <a:gridCol w="3749040"/>
               </a:tblGrid>
               <a:tr h="384048">
                 <a:tc>
@@ -5747,7 +5527,7 @@
                     <a:lstStyle/>
                     <a:p>
                       <a:pPr>
-                        <a:defRPr sz="1000" b="1">
+                        <a:defRPr b="1" sz="1000">
                           <a:solidFill>
                             <a:srgbClr val="FFFFFF"/>
                           </a:solidFill>
@@ -5770,7 +5550,7 @@
                     <a:lstStyle/>
                     <a:p>
                       <a:pPr>
-                        <a:defRPr sz="1000" b="1">
+                        <a:defRPr b="1" sz="1000">
                           <a:solidFill>
                             <a:srgbClr val="FFFFFF"/>
                           </a:solidFill>
@@ -5793,7 +5573,7 @@
                     <a:lstStyle/>
                     <a:p>
                       <a:pPr>
-                        <a:defRPr sz="1000" b="1">
+                        <a:defRPr b="1" sz="1000">
                           <a:solidFill>
                             <a:srgbClr val="FFFFFF"/>
                           </a:solidFill>
@@ -5810,11 +5590,6 @@
                     </a:solidFill>
                   </a:tcPr>
                 </a:tc>
-                <a:extLst>
-                  <a:ext uri="{0D108BD9-81ED-4DB2-BD59-A6C34878D82A}">
-                    <a16:rowId xmlns:a16="http://schemas.microsoft.com/office/drawing/2014/main" val="10000"/>
-                  </a:ext>
-                </a:extLst>
               </a:tr>
               <a:tr h="384048">
                 <a:tc>
@@ -5862,11 +5637,6 @@
                   </a:txBody>
                   <a:tcPr/>
                 </a:tc>
-                <a:extLst>
-                  <a:ext uri="{0D108BD9-81ED-4DB2-BD59-A6C34878D82A}">
-                    <a16:rowId xmlns:a16="http://schemas.microsoft.com/office/drawing/2014/main" val="10001"/>
-                  </a:ext>
-                </a:extLst>
               </a:tr>
               <a:tr h="384048">
                 <a:tc>
@@ -5914,11 +5684,6 @@
                   </a:txBody>
                   <a:tcPr/>
                 </a:tc>
-                <a:extLst>
-                  <a:ext uri="{0D108BD9-81ED-4DB2-BD59-A6C34878D82A}">
-                    <a16:rowId xmlns:a16="http://schemas.microsoft.com/office/drawing/2014/main" val="10002"/>
-                  </a:ext>
-                </a:extLst>
               </a:tr>
               <a:tr h="384048">
                 <a:tc>
@@ -5966,11 +5731,6 @@
                   </a:txBody>
                   <a:tcPr/>
                 </a:tc>
-                <a:extLst>
-                  <a:ext uri="{0D108BD9-81ED-4DB2-BD59-A6C34878D82A}">
-                    <a16:rowId xmlns:a16="http://schemas.microsoft.com/office/drawing/2014/main" val="10003"/>
-                  </a:ext>
-                </a:extLst>
               </a:tr>
               <a:tr h="384048">
                 <a:tc>
@@ -6018,11 +5778,6 @@
                   </a:txBody>
                   <a:tcPr/>
                 </a:tc>
-                <a:extLst>
-                  <a:ext uri="{0D108BD9-81ED-4DB2-BD59-A6C34878D82A}">
-                    <a16:rowId xmlns:a16="http://schemas.microsoft.com/office/drawing/2014/main" val="10004"/>
-                  </a:ext>
-                </a:extLst>
               </a:tr>
               <a:tr h="384048">
                 <a:tc>
@@ -6070,11 +5825,6 @@
                   </a:txBody>
                   <a:tcPr/>
                 </a:tc>
-                <a:extLst>
-                  <a:ext uri="{0D108BD9-81ED-4DB2-BD59-A6C34878D82A}">
-                    <a16:rowId xmlns:a16="http://schemas.microsoft.com/office/drawing/2014/main" val="10005"/>
-                  </a:ext>
-                </a:extLst>
               </a:tr>
             </a:tbl>
           </a:graphicData>
@@ -6089,7 +5839,7 @@
 </file>
 
 <file path=ppt/slides/slide16.xml><?xml version="1.0" encoding="utf-8"?>
-<p:sld xmlns:a="http://schemas.openxmlformats.org/drawingml/2006/main" xmlns:r="http://schemas.openxmlformats.org/officeDocument/2006/relationships" xmlns:p="http://schemas.openxmlformats.org/presentationml/2006/main">
+<p:sld xmlns:a="http://schemas.openxmlformats.org/drawingml/2006/main" xmlns:p="http://schemas.openxmlformats.org/presentationml/2006/main" xmlns:r="http://schemas.openxmlformats.org/officeDocument/2006/relationships">
   <p:cSld>
     <p:bg>
       <p:bgPr>
@@ -6105,14 +5855,7 @@
         <p:cNvGrpSpPr/>
         <p:nvPr/>
       </p:nvGrpSpPr>
-      <p:grpSpPr>
-        <a:xfrm>
-          <a:off x="0" y="0"/>
-          <a:ext cx="0" cy="0"/>
-          <a:chOff x="0" y="0"/>
-          <a:chExt cx="0" cy="0"/>
-        </a:xfrm>
-      </p:grpSpPr>
+      <p:grpSpPr/>
       <p:sp>
         <p:nvSpPr>
           <p:cNvPr id="2" name="TextBox 1"/>
@@ -6157,7 +5900,7 @@
         <p:spPr>
           <a:xfrm>
             <a:off x="731520" y="1371600"/>
-            <a:ext cx="10515600" cy="1882567"/>
+            <a:ext cx="10515600" cy="5029200"/>
           </a:xfrm>
           <a:prstGeom prst="rect">
             <a:avLst/>
@@ -6169,9 +5912,7 @@
             <a:spAutoFit/>
           </a:bodyPr>
           <a:lstStyle/>
-          <a:p>
-            <a:endParaRPr dirty="0"/>
-          </a:p>
+          <a:p/>
           <a:p>
             <a:pPr>
               <a:spcAft>
@@ -6184,188 +5925,7 @@
               </a:defRPr>
             </a:pPr>
             <a:r>
-              <a:rPr dirty="0">
-                <a:solidFill>
-                  <a:schemeClr val="bg1"/>
-                </a:solidFill>
-              </a:rPr>
-              <a:t>✔ Khai </a:t>
-            </a:r>
-            <a:r>
-              <a:rPr dirty="0" err="1">
-                <a:solidFill>
-                  <a:schemeClr val="bg1"/>
-                </a:solidFill>
-              </a:rPr>
-              <a:t>thác</a:t>
-            </a:r>
-            <a:r>
-              <a:rPr dirty="0">
-                <a:solidFill>
-                  <a:schemeClr val="bg1"/>
-                </a:solidFill>
-              </a:rPr>
-              <a:t> </a:t>
-            </a:r>
-            <a:r>
-              <a:rPr dirty="0" err="1">
-                <a:solidFill>
-                  <a:schemeClr val="bg1"/>
-                </a:solidFill>
-              </a:rPr>
-              <a:t>dữ</a:t>
-            </a:r>
-            <a:r>
-              <a:rPr dirty="0">
-                <a:solidFill>
-                  <a:schemeClr val="bg1"/>
-                </a:solidFill>
-              </a:rPr>
-              <a:t> </a:t>
-            </a:r>
-            <a:r>
-              <a:rPr dirty="0" err="1">
-                <a:solidFill>
-                  <a:schemeClr val="bg1"/>
-                </a:solidFill>
-              </a:rPr>
-              <a:t>liệu</a:t>
-            </a:r>
-            <a:r>
-              <a:rPr dirty="0">
-                <a:solidFill>
-                  <a:schemeClr val="bg1"/>
-                </a:solidFill>
-              </a:rPr>
-              <a:t> </a:t>
-            </a:r>
-            <a:r>
-              <a:rPr dirty="0" err="1">
-                <a:solidFill>
-                  <a:schemeClr val="bg1"/>
-                </a:solidFill>
-              </a:rPr>
-              <a:t>tương</a:t>
-            </a:r>
-            <a:r>
-              <a:rPr dirty="0">
-                <a:solidFill>
-                  <a:schemeClr val="bg1"/>
-                </a:solidFill>
-              </a:rPr>
-              <a:t> </a:t>
-            </a:r>
-            <a:r>
-              <a:rPr dirty="0" err="1">
-                <a:solidFill>
-                  <a:schemeClr val="bg1"/>
-                </a:solidFill>
-              </a:rPr>
-              <a:t>tác</a:t>
-            </a:r>
-            <a:r>
-              <a:rPr dirty="0">
-                <a:solidFill>
-                  <a:schemeClr val="bg1"/>
-                </a:solidFill>
-              </a:rPr>
-              <a:t> MXH </a:t>
-            </a:r>
-            <a:r>
-              <a:rPr dirty="0" err="1">
-                <a:solidFill>
-                  <a:schemeClr val="bg1"/>
-                </a:solidFill>
-              </a:rPr>
-              <a:t>ẩm</a:t>
-            </a:r>
-            <a:r>
-              <a:rPr dirty="0">
-                <a:solidFill>
-                  <a:schemeClr val="bg1"/>
-                </a:solidFill>
-              </a:rPr>
-              <a:t> </a:t>
-            </a:r>
-            <a:r>
-              <a:rPr dirty="0" err="1">
-                <a:solidFill>
-                  <a:schemeClr val="bg1"/>
-                </a:solidFill>
-              </a:rPr>
-              <a:t>thực</a:t>
-            </a:r>
-            <a:r>
-              <a:rPr dirty="0">
-                <a:solidFill>
-                  <a:schemeClr val="bg1"/>
-                </a:solidFill>
-              </a:rPr>
-              <a:t> VN </a:t>
-            </a:r>
-            <a:r>
-              <a:rPr dirty="0" err="1">
-                <a:solidFill>
-                  <a:schemeClr val="bg1"/>
-                </a:solidFill>
-              </a:rPr>
-              <a:t>bằng</a:t>
-            </a:r>
-            <a:r>
-              <a:rPr dirty="0">
-                <a:solidFill>
-                  <a:schemeClr val="bg1"/>
-                </a:solidFill>
-              </a:rPr>
-              <a:t> 4 </a:t>
-            </a:r>
-            <a:r>
-              <a:rPr dirty="0" err="1">
-                <a:solidFill>
-                  <a:schemeClr val="bg1"/>
-                </a:solidFill>
-              </a:rPr>
-              <a:t>họ</a:t>
-            </a:r>
-            <a:r>
-              <a:rPr dirty="0">
-                <a:solidFill>
-                  <a:schemeClr val="bg1"/>
-                </a:solidFill>
-              </a:rPr>
-              <a:t> </a:t>
-            </a:r>
-            <a:r>
-              <a:rPr dirty="0" err="1">
-                <a:solidFill>
-                  <a:schemeClr val="bg1"/>
-                </a:solidFill>
-              </a:rPr>
-              <a:t>phương</a:t>
-            </a:r>
-            <a:r>
-              <a:rPr dirty="0">
-                <a:solidFill>
-                  <a:schemeClr val="bg1"/>
-                </a:solidFill>
-              </a:rPr>
-              <a:t> </a:t>
-            </a:r>
-            <a:r>
-              <a:rPr dirty="0" err="1">
-                <a:solidFill>
-                  <a:schemeClr val="bg1"/>
-                </a:solidFill>
-              </a:rPr>
-              <a:t>pháp</a:t>
-            </a:r>
-            <a:r>
-              <a:rPr dirty="0">
-                <a:solidFill>
-                  <a:schemeClr val="bg1"/>
-                </a:solidFill>
-              </a:rPr>
-              <a:t> KN.</a:t>
+              <a:t>✔ Khai thác dữ liệu tương tác MXH ẩm thực VN bằng 4 họ phương pháp KN.</a:t>
             </a:r>
           </a:p>
           <a:p>
@@ -6380,76 +5940,7 @@
               </a:defRPr>
             </a:pPr>
             <a:r>
-              <a:rPr dirty="0">
-                <a:solidFill>
-                  <a:schemeClr val="bg1"/>
-                </a:solidFill>
-              </a:rPr>
-              <a:t>✔ NCF </a:t>
-            </a:r>
-            <a:r>
-              <a:rPr dirty="0" err="1">
-                <a:solidFill>
-                  <a:schemeClr val="bg1"/>
-                </a:solidFill>
-              </a:rPr>
-              <a:t>tốt</a:t>
-            </a:r>
-            <a:r>
-              <a:rPr dirty="0">
-                <a:solidFill>
-                  <a:schemeClr val="bg1"/>
-                </a:solidFill>
-              </a:rPr>
-              <a:t> </a:t>
-            </a:r>
-            <a:r>
-              <a:rPr dirty="0" err="1">
-                <a:solidFill>
-                  <a:schemeClr val="bg1"/>
-                </a:solidFill>
-              </a:rPr>
-              <a:t>nhất</a:t>
-            </a:r>
-            <a:r>
-              <a:rPr dirty="0">
-                <a:solidFill>
-                  <a:schemeClr val="bg1"/>
-                </a:solidFill>
-              </a:rPr>
-              <a:t> Rating Prediction; User-CF </a:t>
-            </a:r>
-            <a:r>
-              <a:rPr dirty="0" err="1">
-                <a:solidFill>
-                  <a:schemeClr val="bg1"/>
-                </a:solidFill>
-              </a:rPr>
-              <a:t>tốt</a:t>
-            </a:r>
-            <a:r>
-              <a:rPr dirty="0">
-                <a:solidFill>
-                  <a:schemeClr val="bg1"/>
-                </a:solidFill>
-              </a:rPr>
-              <a:t> </a:t>
-            </a:r>
-            <a:r>
-              <a:rPr dirty="0" err="1">
-                <a:solidFill>
-                  <a:schemeClr val="bg1"/>
-                </a:solidFill>
-              </a:rPr>
-              <a:t>nhất</a:t>
-            </a:r>
-            <a:r>
-              <a:rPr dirty="0">
-                <a:solidFill>
-                  <a:schemeClr val="bg1"/>
-                </a:solidFill>
-              </a:rPr>
-              <a:t> Top-K Ranking.</a:t>
+              <a:t>✔ NCF tốt nhất Rating Prediction; User-CF tốt nhất Top-K Ranking.</a:t>
             </a:r>
           </a:p>
           <a:p>
@@ -6464,204 +5955,7 @@
               </a:defRPr>
             </a:pPr>
             <a:r>
-              <a:rPr dirty="0">
-                <a:solidFill>
-                  <a:schemeClr val="bg1"/>
-                </a:solidFill>
-              </a:rPr>
-              <a:t>✔ </a:t>
-            </a:r>
-            <a:r>
-              <a:rPr dirty="0" err="1">
-                <a:solidFill>
-                  <a:schemeClr val="bg1"/>
-                </a:solidFill>
-              </a:rPr>
-              <a:t>Chênh</a:t>
-            </a:r>
-            <a:r>
-              <a:rPr dirty="0">
-                <a:solidFill>
-                  <a:schemeClr val="bg1"/>
-                </a:solidFill>
-              </a:rPr>
-              <a:t> </a:t>
-            </a:r>
-            <a:r>
-              <a:rPr dirty="0" err="1">
-                <a:solidFill>
-                  <a:schemeClr val="bg1"/>
-                </a:solidFill>
-              </a:rPr>
-              <a:t>lệch</a:t>
-            </a:r>
-            <a:r>
-              <a:rPr dirty="0">
-                <a:solidFill>
-                  <a:schemeClr val="bg1"/>
-                </a:solidFill>
-              </a:rPr>
-              <a:t> </a:t>
-            </a:r>
-            <a:r>
-              <a:rPr dirty="0" err="1">
-                <a:solidFill>
-                  <a:schemeClr val="bg1"/>
-                </a:solidFill>
-              </a:rPr>
-              <a:t>giữa</a:t>
-            </a:r>
-            <a:r>
-              <a:rPr dirty="0">
-                <a:solidFill>
-                  <a:schemeClr val="bg1"/>
-                </a:solidFill>
-              </a:rPr>
-              <a:t> </a:t>
-            </a:r>
-            <a:r>
-              <a:rPr dirty="0" err="1">
-                <a:solidFill>
-                  <a:schemeClr val="bg1"/>
-                </a:solidFill>
-              </a:rPr>
-              <a:t>mô</a:t>
-            </a:r>
-            <a:r>
-              <a:rPr dirty="0">
-                <a:solidFill>
-                  <a:schemeClr val="bg1"/>
-                </a:solidFill>
-              </a:rPr>
-              <a:t> </a:t>
-            </a:r>
-            <a:r>
-              <a:rPr dirty="0" err="1">
-                <a:solidFill>
-                  <a:schemeClr val="bg1"/>
-                </a:solidFill>
-              </a:rPr>
-              <a:t>hình</a:t>
-            </a:r>
-            <a:r>
-              <a:rPr dirty="0">
-                <a:solidFill>
-                  <a:schemeClr val="bg1"/>
-                </a:solidFill>
-              </a:rPr>
-              <a:t> ranking </a:t>
-            </a:r>
-            <a:r>
-              <a:rPr dirty="0" err="1">
-                <a:solidFill>
-                  <a:schemeClr val="bg1"/>
-                </a:solidFill>
-              </a:rPr>
-              <a:t>nhỏ</a:t>
-            </a:r>
-            <a:r>
-              <a:rPr dirty="0">
-                <a:solidFill>
-                  <a:schemeClr val="bg1"/>
-                </a:solidFill>
-              </a:rPr>
-              <a:t> (1–4%) — </a:t>
-            </a:r>
-            <a:r>
-              <a:rPr dirty="0" err="1">
-                <a:solidFill>
-                  <a:schemeClr val="bg1"/>
-                </a:solidFill>
-              </a:rPr>
-              <a:t>cần</a:t>
-            </a:r>
-            <a:r>
-              <a:rPr dirty="0">
-                <a:solidFill>
-                  <a:schemeClr val="bg1"/>
-                </a:solidFill>
-              </a:rPr>
-              <a:t> </a:t>
-            </a:r>
-            <a:r>
-              <a:rPr dirty="0" err="1">
-                <a:solidFill>
-                  <a:schemeClr val="bg1"/>
-                </a:solidFill>
-              </a:rPr>
-              <a:t>thận</a:t>
-            </a:r>
-            <a:r>
-              <a:rPr dirty="0">
-                <a:solidFill>
-                  <a:schemeClr val="bg1"/>
-                </a:solidFill>
-              </a:rPr>
-              <a:t> </a:t>
-            </a:r>
-            <a:r>
-              <a:rPr dirty="0" err="1">
-                <a:solidFill>
-                  <a:schemeClr val="bg1"/>
-                </a:solidFill>
-              </a:rPr>
-              <a:t>trọng</a:t>
-            </a:r>
-            <a:r>
-              <a:rPr dirty="0">
-                <a:solidFill>
-                  <a:schemeClr val="bg1"/>
-                </a:solidFill>
-              </a:rPr>
-              <a:t> </a:t>
-            </a:r>
-            <a:r>
-              <a:rPr dirty="0" err="1">
-                <a:solidFill>
-                  <a:schemeClr val="bg1"/>
-                </a:solidFill>
-              </a:rPr>
-              <a:t>khi</a:t>
-            </a:r>
-            <a:r>
-              <a:rPr dirty="0">
-                <a:solidFill>
-                  <a:schemeClr val="bg1"/>
-                </a:solidFill>
-              </a:rPr>
-              <a:t> </a:t>
-            </a:r>
-            <a:r>
-              <a:rPr dirty="0" err="1">
-                <a:solidFill>
-                  <a:schemeClr val="bg1"/>
-                </a:solidFill>
-              </a:rPr>
-              <a:t>khái</a:t>
-            </a:r>
-            <a:r>
-              <a:rPr dirty="0">
-                <a:solidFill>
-                  <a:schemeClr val="bg1"/>
-                </a:solidFill>
-              </a:rPr>
-              <a:t> </a:t>
-            </a:r>
-            <a:r>
-              <a:rPr dirty="0" err="1">
-                <a:solidFill>
-                  <a:schemeClr val="bg1"/>
-                </a:solidFill>
-              </a:rPr>
-              <a:t>quát</a:t>
-            </a:r>
-            <a:r>
-              <a:rPr dirty="0">
-                <a:solidFill>
-                  <a:schemeClr val="bg1"/>
-                </a:solidFill>
-              </a:rPr>
-              <a:t>.</a:t>
+              <a:t>✔ Chênh lệch giữa mô hình ranking nhỏ (1–4%) — cần thận trọng khi khái quát.</a:t>
             </a:r>
           </a:p>
           <a:p>
@@ -6676,92 +5970,7 @@
               </a:defRPr>
             </a:pPr>
             <a:r>
-              <a:rPr dirty="0">
-                <a:solidFill>
-                  <a:schemeClr val="bg1"/>
-                </a:solidFill>
-              </a:rPr>
-              <a:t>✔ </a:t>
-            </a:r>
-            <a:r>
-              <a:rPr dirty="0" err="1">
-                <a:solidFill>
-                  <a:schemeClr val="bg1"/>
-                </a:solidFill>
-              </a:rPr>
-              <a:t>Hạn</a:t>
-            </a:r>
-            <a:r>
-              <a:rPr dirty="0">
-                <a:solidFill>
-                  <a:schemeClr val="bg1"/>
-                </a:solidFill>
-              </a:rPr>
-              <a:t> </a:t>
-            </a:r>
-            <a:r>
-              <a:rPr dirty="0" err="1">
-                <a:solidFill>
-                  <a:schemeClr val="bg1"/>
-                </a:solidFill>
-              </a:rPr>
-              <a:t>chế</a:t>
-            </a:r>
-            <a:r>
-              <a:rPr dirty="0">
-                <a:solidFill>
-                  <a:schemeClr val="bg1"/>
-                </a:solidFill>
-              </a:rPr>
-              <a:t>: dataset </a:t>
-            </a:r>
-            <a:r>
-              <a:rPr dirty="0" err="1">
-                <a:solidFill>
-                  <a:schemeClr val="bg1"/>
-                </a:solidFill>
-              </a:rPr>
-              <a:t>có</a:t>
-            </a:r>
-            <a:r>
-              <a:rPr dirty="0">
-                <a:solidFill>
-                  <a:schemeClr val="bg1"/>
-                </a:solidFill>
-              </a:rPr>
-              <a:t> </a:t>
-            </a:r>
-            <a:r>
-              <a:rPr dirty="0" err="1">
-                <a:solidFill>
-                  <a:schemeClr val="bg1"/>
-                </a:solidFill>
-              </a:rPr>
-              <a:t>sẵn</a:t>
-            </a:r>
-            <a:r>
-              <a:rPr dirty="0">
-                <a:solidFill>
-                  <a:schemeClr val="bg1"/>
-                </a:solidFill>
-              </a:rPr>
-              <a:t>, </a:t>
-            </a:r>
-            <a:r>
-              <a:rPr dirty="0" err="1">
-                <a:solidFill>
-                  <a:schemeClr val="bg1"/>
-                </a:solidFill>
-              </a:rPr>
-              <a:t>chưa</a:t>
-            </a:r>
-            <a:r>
-              <a:rPr dirty="0">
-                <a:solidFill>
-                  <a:schemeClr val="bg1"/>
-                </a:solidFill>
-              </a:rPr>
-              <a:t> significance test, MLP fallback.</a:t>
+              <a:t>✔ Hạn chế: dataset có sẵn, chưa significance test, MLP fallback.</a:t>
             </a:r>
           </a:p>
           <a:p>
@@ -6776,92 +5985,7 @@
               </a:defRPr>
             </a:pPr>
             <a:r>
-              <a:rPr dirty="0">
-                <a:solidFill>
-                  <a:schemeClr val="bg1"/>
-                </a:solidFill>
-              </a:rPr>
-              <a:t>✔ </a:t>
-            </a:r>
-            <a:r>
-              <a:rPr dirty="0" err="1">
-                <a:solidFill>
-                  <a:schemeClr val="bg1"/>
-                </a:solidFill>
-              </a:rPr>
-              <a:t>Hướng</a:t>
-            </a:r>
-            <a:r>
-              <a:rPr dirty="0">
-                <a:solidFill>
-                  <a:schemeClr val="bg1"/>
-                </a:solidFill>
-              </a:rPr>
-              <a:t> </a:t>
-            </a:r>
-            <a:r>
-              <a:rPr dirty="0" err="1">
-                <a:solidFill>
-                  <a:schemeClr val="bg1"/>
-                </a:solidFill>
-              </a:rPr>
-              <a:t>phát</a:t>
-            </a:r>
-            <a:r>
-              <a:rPr dirty="0">
-                <a:solidFill>
-                  <a:schemeClr val="bg1"/>
-                </a:solidFill>
-              </a:rPr>
-              <a:t> </a:t>
-            </a:r>
-            <a:r>
-              <a:rPr dirty="0" err="1">
-                <a:solidFill>
-                  <a:schemeClr val="bg1"/>
-                </a:solidFill>
-              </a:rPr>
-              <a:t>triển</a:t>
-            </a:r>
-            <a:r>
-              <a:rPr dirty="0">
-                <a:solidFill>
-                  <a:schemeClr val="bg1"/>
-                </a:solidFill>
-              </a:rPr>
-              <a:t>: Hybrid, embedding VN, implicit feedback </a:t>
-            </a:r>
-            <a:r>
-              <a:rPr dirty="0" err="1">
-                <a:solidFill>
-                  <a:schemeClr val="bg1"/>
-                </a:solidFill>
-              </a:rPr>
-              <a:t>thực</a:t>
-            </a:r>
-            <a:r>
-              <a:rPr dirty="0">
-                <a:solidFill>
-                  <a:schemeClr val="bg1"/>
-                </a:solidFill>
-              </a:rPr>
-              <a:t> </a:t>
-            </a:r>
-            <a:r>
-              <a:rPr dirty="0" err="1">
-                <a:solidFill>
-                  <a:schemeClr val="bg1"/>
-                </a:solidFill>
-              </a:rPr>
-              <a:t>tế</a:t>
-            </a:r>
-            <a:r>
-              <a:rPr dirty="0">
-                <a:solidFill>
-                  <a:schemeClr val="bg1"/>
-                </a:solidFill>
-              </a:rPr>
-              <a:t>.</a:t>
+              <a:t>✔ Hướng phát triển: Hybrid, embedding VN, implicit feedback thực tế.</a:t>
             </a:r>
           </a:p>
         </p:txBody>
@@ -6875,7 +5999,7 @@
 </file>
 
 <file path=ppt/slides/slide17.xml><?xml version="1.0" encoding="utf-8"?>
-<p:sld xmlns:a="http://schemas.openxmlformats.org/drawingml/2006/main" xmlns:r="http://schemas.openxmlformats.org/officeDocument/2006/relationships" xmlns:p="http://schemas.openxmlformats.org/presentationml/2006/main">
+<p:sld xmlns:a="http://schemas.openxmlformats.org/drawingml/2006/main" xmlns:p="http://schemas.openxmlformats.org/presentationml/2006/main" xmlns:r="http://schemas.openxmlformats.org/officeDocument/2006/relationships">
   <p:cSld>
     <p:bg>
       <p:bgPr>
@@ -6891,14 +6015,7 @@
         <p:cNvGrpSpPr/>
         <p:nvPr/>
       </p:nvGrpSpPr>
-      <p:grpSpPr>
-        <a:xfrm>
-          <a:off x="0" y="0"/>
-          <a:ext cx="0" cy="0"/>
-          <a:chOff x="0" y="0"/>
-          <a:chExt cx="0" cy="0"/>
-        </a:xfrm>
-      </p:grpSpPr>
+      <p:grpSpPr/>
       <p:sp>
         <p:nvSpPr>
           <p:cNvPr id="2" name="TextBox 1"/>
@@ -6955,7 +6072,7 @@
 </file>
 
 <file path=ppt/slides/slide2.xml><?xml version="1.0" encoding="utf-8"?>
-<p:sld xmlns:a="http://schemas.openxmlformats.org/drawingml/2006/main" xmlns:r="http://schemas.openxmlformats.org/officeDocument/2006/relationships" xmlns:p="http://schemas.openxmlformats.org/presentationml/2006/main">
+<p:sld xmlns:a="http://schemas.openxmlformats.org/drawingml/2006/main" xmlns:p="http://schemas.openxmlformats.org/presentationml/2006/main" xmlns:r="http://schemas.openxmlformats.org/officeDocument/2006/relationships">
   <p:cSld>
     <p:bg>
       <p:bgPr>
@@ -6971,14 +6088,7 @@
         <p:cNvGrpSpPr/>
         <p:nvPr/>
       </p:nvGrpSpPr>
-      <p:grpSpPr>
-        <a:xfrm>
-          <a:off x="0" y="0"/>
-          <a:ext cx="0" cy="0"/>
-          <a:chOff x="0" y="0"/>
-          <a:chExt cx="0" cy="0"/>
-        </a:xfrm>
-      </p:grpSpPr>
+      <p:grpSpPr/>
       <p:sp>
         <p:nvSpPr>
           <p:cNvPr id="2" name="TextBox 1"/>
@@ -7054,7 +6164,6 @@
           <a:lstStyle/>
           <a:p>
             <a:pPr algn="ctr"/>
-            <a:endParaRPr/>
           </a:p>
         </p:txBody>
       </p:sp>
@@ -7114,9 +6223,7 @@
             <a:spAutoFit/>
           </a:bodyPr>
           <a:lstStyle/>
-          <a:p>
-            <a:endParaRPr/>
-          </a:p>
+          <a:p/>
           <a:p>
             <a:pPr>
               <a:spcAft>
@@ -7248,7 +6355,7 @@
 </file>
 
 <file path=ppt/slides/slide3.xml><?xml version="1.0" encoding="utf-8"?>
-<p:sld xmlns:a="http://schemas.openxmlformats.org/drawingml/2006/main" xmlns:r="http://schemas.openxmlformats.org/officeDocument/2006/relationships" xmlns:p="http://schemas.openxmlformats.org/presentationml/2006/main">
+<p:sld xmlns:a="http://schemas.openxmlformats.org/drawingml/2006/main" xmlns:p="http://schemas.openxmlformats.org/presentationml/2006/main" xmlns:r="http://schemas.openxmlformats.org/officeDocument/2006/relationships">
   <p:cSld>
     <p:bg>
       <p:bgPr>
@@ -7264,14 +6371,7 @@
         <p:cNvGrpSpPr/>
         <p:nvPr/>
       </p:nvGrpSpPr>
-      <p:grpSpPr>
-        <a:xfrm>
-          <a:off x="0" y="0"/>
-          <a:ext cx="0" cy="0"/>
-          <a:chOff x="0" y="0"/>
-          <a:chExt cx="0" cy="0"/>
-        </a:xfrm>
-      </p:grpSpPr>
+      <p:grpSpPr/>
       <p:sp>
         <p:nvSpPr>
           <p:cNvPr id="2" name="TextBox 1"/>
@@ -7347,7 +6447,6 @@
           <a:lstStyle/>
           <a:p>
             <a:pPr algn="ctr"/>
-            <a:endParaRPr/>
           </a:p>
         </p:txBody>
       </p:sp>
@@ -7561,7 +6660,7 @@
 </file>
 
 <file path=ppt/slides/slide4.xml><?xml version="1.0" encoding="utf-8"?>
-<p:sld xmlns:a="http://schemas.openxmlformats.org/drawingml/2006/main" xmlns:r="http://schemas.openxmlformats.org/officeDocument/2006/relationships" xmlns:p="http://schemas.openxmlformats.org/presentationml/2006/main">
+<p:sld xmlns:a="http://schemas.openxmlformats.org/drawingml/2006/main" xmlns:p="http://schemas.openxmlformats.org/presentationml/2006/main" xmlns:r="http://schemas.openxmlformats.org/officeDocument/2006/relationships">
   <p:cSld>
     <p:bg>
       <p:bgPr>
@@ -7577,14 +6676,7 @@
         <p:cNvGrpSpPr/>
         <p:nvPr/>
       </p:nvGrpSpPr>
-      <p:grpSpPr>
-        <a:xfrm>
-          <a:off x="0" y="0"/>
-          <a:ext cx="0" cy="0"/>
-          <a:chOff x="0" y="0"/>
-          <a:chExt cx="0" cy="0"/>
-        </a:xfrm>
-      </p:grpSpPr>
+      <p:grpSpPr/>
       <p:sp>
         <p:nvSpPr>
           <p:cNvPr id="2" name="TextBox 1"/>
@@ -7660,7 +6752,6 @@
           <a:lstStyle/>
           <a:p>
             <a:pPr algn="ctr"/>
-            <a:endParaRPr/>
           </a:p>
         </p:txBody>
       </p:sp>
@@ -7720,9 +6811,7 @@
             <a:spAutoFit/>
           </a:bodyPr>
           <a:lstStyle/>
-          <a:p>
-            <a:endParaRPr/>
-          </a:p>
+          <a:p/>
           <a:p>
             <a:pPr>
               <a:spcAft>
@@ -7779,7 +6868,7 @@
 </file>
 
 <file path=ppt/slides/slide5.xml><?xml version="1.0" encoding="utf-8"?>
-<p:sld xmlns:a="http://schemas.openxmlformats.org/drawingml/2006/main" xmlns:r="http://schemas.openxmlformats.org/officeDocument/2006/relationships" xmlns:p="http://schemas.openxmlformats.org/presentationml/2006/main">
+<p:sld xmlns:a="http://schemas.openxmlformats.org/drawingml/2006/main" xmlns:p="http://schemas.openxmlformats.org/presentationml/2006/main" xmlns:r="http://schemas.openxmlformats.org/officeDocument/2006/relationships">
   <p:cSld>
     <p:bg>
       <p:bgPr>
@@ -7795,14 +6884,7 @@
         <p:cNvGrpSpPr/>
         <p:nvPr/>
       </p:nvGrpSpPr>
-      <p:grpSpPr>
-        <a:xfrm>
-          <a:off x="0" y="0"/>
-          <a:ext cx="0" cy="0"/>
-          <a:chOff x="0" y="0"/>
-          <a:chExt cx="0" cy="0"/>
-        </a:xfrm>
-      </p:grpSpPr>
+      <p:grpSpPr/>
       <p:sp>
         <p:nvSpPr>
           <p:cNvPr id="2" name="TextBox 1"/>
@@ -7878,7 +6960,6 @@
           <a:lstStyle/>
           <a:p>
             <a:pPr algn="ctr"/>
-            <a:endParaRPr/>
           </a:p>
         </p:txBody>
       </p:sp>
@@ -7946,7 +7027,6 @@
                 </a:solidFill>
               </a:defRPr>
             </a:pPr>
-            <a:endParaRPr/>
           </a:p>
         </p:txBody>
       </p:sp>
@@ -7990,7 +7070,6 @@
           <a:lstStyle/>
           <a:p>
             <a:pPr algn="ctr"/>
-            <a:endParaRPr/>
           </a:p>
         </p:txBody>
       </p:sp>
@@ -8048,34 +7127,10 @@
                 <a:tableStyleId>{5C22544A-7EE6-4342-B048-85BDC9FD1C3A}</a:tableStyleId>
               </a:tblPr>
               <a:tblGrid>
-                <a:gridCol w="2811780">
-                  <a:extLst>
-                    <a:ext uri="{9D8B030D-6E8A-4147-A177-3AD203B41FA5}">
-                      <a16:colId xmlns:a16="http://schemas.microsoft.com/office/drawing/2014/main" val="20000"/>
-                    </a:ext>
-                  </a:extLst>
-                </a:gridCol>
-                <a:gridCol w="2811780">
-                  <a:extLst>
-                    <a:ext uri="{9D8B030D-6E8A-4147-A177-3AD203B41FA5}">
-                      <a16:colId xmlns:a16="http://schemas.microsoft.com/office/drawing/2014/main" val="20001"/>
-                    </a:ext>
-                  </a:extLst>
-                </a:gridCol>
-                <a:gridCol w="2811780">
-                  <a:extLst>
-                    <a:ext uri="{9D8B030D-6E8A-4147-A177-3AD203B41FA5}">
-                      <a16:colId xmlns:a16="http://schemas.microsoft.com/office/drawing/2014/main" val="20002"/>
-                    </a:ext>
-                  </a:extLst>
-                </a:gridCol>
-                <a:gridCol w="2811780">
-                  <a:extLst>
-                    <a:ext uri="{9D8B030D-6E8A-4147-A177-3AD203B41FA5}">
-                      <a16:colId xmlns:a16="http://schemas.microsoft.com/office/drawing/2014/main" val="20003"/>
-                    </a:ext>
-                  </a:extLst>
-                </a:gridCol>
+                <a:gridCol w="2811780"/>
+                <a:gridCol w="2811780"/>
+                <a:gridCol w="2811780"/>
+                <a:gridCol w="2811780"/>
               </a:tblGrid>
               <a:tr h="384048">
                 <a:tc>
@@ -8084,7 +7139,7 @@
                     <a:lstStyle/>
                     <a:p>
                       <a:pPr>
-                        <a:defRPr sz="1000" b="1">
+                        <a:defRPr b="1" sz="1000">
                           <a:solidFill>
                             <a:srgbClr val="FFFFFF"/>
                           </a:solidFill>
@@ -8107,7 +7162,7 @@
                     <a:lstStyle/>
                     <a:p>
                       <a:pPr>
-                        <a:defRPr sz="1000" b="1">
+                        <a:defRPr b="1" sz="1000">
                           <a:solidFill>
                             <a:srgbClr val="FFFFFF"/>
                           </a:solidFill>
@@ -8130,7 +7185,7 @@
                     <a:lstStyle/>
                     <a:p>
                       <a:pPr>
-                        <a:defRPr sz="1000" b="1">
+                        <a:defRPr b="1" sz="1000">
                           <a:solidFill>
                             <a:srgbClr val="FFFFFF"/>
                           </a:solidFill>
@@ -8153,7 +7208,7 @@
                     <a:lstStyle/>
                     <a:p>
                       <a:pPr>
-                        <a:defRPr sz="1000" b="1">
+                        <a:defRPr b="1" sz="1000">
                           <a:solidFill>
                             <a:srgbClr val="FFFFFF"/>
                           </a:solidFill>
@@ -8170,11 +7225,6 @@
                     </a:solidFill>
                   </a:tcPr>
                 </a:tc>
-                <a:extLst>
-                  <a:ext uri="{0D108BD9-81ED-4DB2-BD59-A6C34878D82A}">
-                    <a16:rowId xmlns:a16="http://schemas.microsoft.com/office/drawing/2014/main" val="10000"/>
-                  </a:ext>
-                </a:extLst>
               </a:tr>
               <a:tr h="384048">
                 <a:tc>
@@ -8237,11 +7287,6 @@
                   </a:txBody>
                   <a:tcPr/>
                 </a:tc>
-                <a:extLst>
-                  <a:ext uri="{0D108BD9-81ED-4DB2-BD59-A6C34878D82A}">
-                    <a16:rowId xmlns:a16="http://schemas.microsoft.com/office/drawing/2014/main" val="10001"/>
-                  </a:ext>
-                </a:extLst>
               </a:tr>
               <a:tr h="384048">
                 <a:tc>
@@ -8304,11 +7349,6 @@
                   </a:txBody>
                   <a:tcPr/>
                 </a:tc>
-                <a:extLst>
-                  <a:ext uri="{0D108BD9-81ED-4DB2-BD59-A6C34878D82A}">
-                    <a16:rowId xmlns:a16="http://schemas.microsoft.com/office/drawing/2014/main" val="10002"/>
-                  </a:ext>
-                </a:extLst>
               </a:tr>
               <a:tr h="384048">
                 <a:tc>
@@ -8371,11 +7411,6 @@
                   </a:txBody>
                   <a:tcPr/>
                 </a:tc>
-                <a:extLst>
-                  <a:ext uri="{0D108BD9-81ED-4DB2-BD59-A6C34878D82A}">
-                    <a16:rowId xmlns:a16="http://schemas.microsoft.com/office/drawing/2014/main" val="10003"/>
-                  </a:ext>
-                </a:extLst>
               </a:tr>
               <a:tr h="384048">
                 <a:tc>
@@ -8438,11 +7473,6 @@
                   </a:txBody>
                   <a:tcPr/>
                 </a:tc>
-                <a:extLst>
-                  <a:ext uri="{0D108BD9-81ED-4DB2-BD59-A6C34878D82A}">
-                    <a16:rowId xmlns:a16="http://schemas.microsoft.com/office/drawing/2014/main" val="10004"/>
-                  </a:ext>
-                </a:extLst>
               </a:tr>
             </a:tbl>
           </a:graphicData>
@@ -8492,7 +7522,7 @@
 </file>
 
 <file path=ppt/slides/slide6.xml><?xml version="1.0" encoding="utf-8"?>
-<p:sld xmlns:a="http://schemas.openxmlformats.org/drawingml/2006/main" xmlns:r="http://schemas.openxmlformats.org/officeDocument/2006/relationships" xmlns:p="http://schemas.openxmlformats.org/presentationml/2006/main">
+<p:sld xmlns:a="http://schemas.openxmlformats.org/drawingml/2006/main" xmlns:p="http://schemas.openxmlformats.org/presentationml/2006/main" xmlns:r="http://schemas.openxmlformats.org/officeDocument/2006/relationships">
   <p:cSld>
     <p:bg>
       <p:bgPr>
@@ -8508,14 +7538,7 @@
         <p:cNvGrpSpPr/>
         <p:nvPr/>
       </p:nvGrpSpPr>
-      <p:grpSpPr>
-        <a:xfrm>
-          <a:off x="0" y="0"/>
-          <a:ext cx="0" cy="0"/>
-          <a:chOff x="0" y="0"/>
-          <a:chExt cx="0" cy="0"/>
-        </a:xfrm>
-      </p:grpSpPr>
+      <p:grpSpPr/>
       <p:sp>
         <p:nvSpPr>
           <p:cNvPr id="2" name="TextBox 1"/>
@@ -8591,7 +7614,6 @@
           <a:lstStyle/>
           <a:p>
             <a:pPr algn="ctr"/>
-            <a:endParaRPr/>
           </a:p>
         </p:txBody>
       </p:sp>
@@ -8820,7 +7842,7 @@
 </file>
 
 <file path=ppt/slides/slide7.xml><?xml version="1.0" encoding="utf-8"?>
-<p:sld xmlns:a="http://schemas.openxmlformats.org/drawingml/2006/main" xmlns:r="http://schemas.openxmlformats.org/officeDocument/2006/relationships" xmlns:p="http://schemas.openxmlformats.org/presentationml/2006/main">
+<p:sld xmlns:a="http://schemas.openxmlformats.org/drawingml/2006/main" xmlns:p="http://schemas.openxmlformats.org/presentationml/2006/main" xmlns:r="http://schemas.openxmlformats.org/officeDocument/2006/relationships">
   <p:cSld>
     <p:bg>
       <p:bgPr>
@@ -8836,14 +7858,7 @@
         <p:cNvGrpSpPr/>
         <p:nvPr/>
       </p:nvGrpSpPr>
-      <p:grpSpPr>
-        <a:xfrm>
-          <a:off x="0" y="0"/>
-          <a:ext cx="0" cy="0"/>
-          <a:chOff x="0" y="0"/>
-          <a:chExt cx="0" cy="0"/>
-        </a:xfrm>
-      </p:grpSpPr>
+      <p:grpSpPr/>
       <p:sp>
         <p:nvSpPr>
           <p:cNvPr id="2" name="TextBox 1"/>
@@ -8919,7 +7934,6 @@
           <a:lstStyle/>
           <a:p>
             <a:pPr algn="ctr"/>
-            <a:endParaRPr/>
           </a:p>
         </p:txBody>
       </p:sp>
@@ -9051,9 +8065,7 @@
             <a:spAutoFit/>
           </a:bodyPr>
           <a:lstStyle/>
-          <a:p>
-            <a:endParaRPr/>
-          </a:p>
+          <a:p/>
           <a:p>
             <a:pPr>
               <a:spcAft>
@@ -9110,7 +8122,7 @@
 </file>
 
 <file path=ppt/slides/slide8.xml><?xml version="1.0" encoding="utf-8"?>
-<p:sld xmlns:a="http://schemas.openxmlformats.org/drawingml/2006/main" xmlns:r="http://schemas.openxmlformats.org/officeDocument/2006/relationships" xmlns:p="http://schemas.openxmlformats.org/presentationml/2006/main">
+<p:sld xmlns:a="http://schemas.openxmlformats.org/drawingml/2006/main" xmlns:p="http://schemas.openxmlformats.org/presentationml/2006/main" xmlns:r="http://schemas.openxmlformats.org/officeDocument/2006/relationships">
   <p:cSld>
     <p:bg>
       <p:bgPr>
@@ -9126,14 +8138,7 @@
         <p:cNvGrpSpPr/>
         <p:nvPr/>
       </p:nvGrpSpPr>
-      <p:grpSpPr>
-        <a:xfrm>
-          <a:off x="0" y="0"/>
-          <a:ext cx="0" cy="0"/>
-          <a:chOff x="0" y="0"/>
-          <a:chExt cx="0" cy="0"/>
-        </a:xfrm>
-      </p:grpSpPr>
+      <p:grpSpPr/>
       <p:sp>
         <p:nvSpPr>
           <p:cNvPr id="2" name="TextBox 1"/>
@@ -9209,7 +8214,6 @@
           <a:lstStyle/>
           <a:p>
             <a:pPr algn="ctr"/>
-            <a:endParaRPr/>
           </a:p>
         </p:txBody>
       </p:sp>
@@ -9290,7 +8294,6 @@
           <a:lstStyle/>
           <a:p>
             <a:pPr algn="ctr"/>
-            <a:endParaRPr/>
           </a:p>
         </p:txBody>
       </p:sp>
@@ -9317,7 +8320,7 @@
           <a:lstStyle/>
           <a:p>
             <a:pPr>
-              <a:defRPr sz="1800" b="1">
+              <a:defRPr b="1" sz="1800">
                 <a:solidFill>
                   <a:srgbClr val="1E3A8A"/>
                 </a:solidFill>
@@ -9391,7 +8394,6 @@
           <a:lstStyle/>
           <a:p>
             <a:pPr algn="ctr"/>
-            <a:endParaRPr/>
           </a:p>
         </p:txBody>
       </p:sp>
@@ -9418,7 +8420,7 @@
           <a:lstStyle/>
           <a:p>
             <a:pPr>
-              <a:defRPr sz="1800" b="1">
+              <a:defRPr b="1" sz="1800">
                 <a:solidFill>
                   <a:srgbClr val="1E3A8A"/>
                 </a:solidFill>
@@ -9492,7 +8494,6 @@
           <a:lstStyle/>
           <a:p>
             <a:pPr algn="ctr"/>
-            <a:endParaRPr/>
           </a:p>
         </p:txBody>
       </p:sp>
@@ -9519,7 +8520,7 @@
           <a:lstStyle/>
           <a:p>
             <a:pPr>
-              <a:defRPr sz="1800" b="1">
+              <a:defRPr b="1" sz="1800">
                 <a:solidFill>
                   <a:srgbClr val="1E3A8A"/>
                 </a:solidFill>
@@ -9593,7 +8594,6 @@
           <a:lstStyle/>
           <a:p>
             <a:pPr algn="ctr"/>
-            <a:endParaRPr/>
           </a:p>
         </p:txBody>
       </p:sp>
@@ -9620,7 +8620,7 @@
           <a:lstStyle/>
           <a:p>
             <a:pPr>
-              <a:defRPr sz="1800" b="1">
+              <a:defRPr b="1" sz="1800">
                 <a:solidFill>
                   <a:srgbClr val="1E3A8A"/>
                 </a:solidFill>
@@ -9661,7 +8661,7 @@
 </file>
 
 <file path=ppt/slides/slide9.xml><?xml version="1.0" encoding="utf-8"?>
-<p:sld xmlns:a="http://schemas.openxmlformats.org/drawingml/2006/main" xmlns:r="http://schemas.openxmlformats.org/officeDocument/2006/relationships" xmlns:p="http://schemas.openxmlformats.org/presentationml/2006/main">
+<p:sld xmlns:a="http://schemas.openxmlformats.org/drawingml/2006/main" xmlns:p="http://schemas.openxmlformats.org/presentationml/2006/main" xmlns:r="http://schemas.openxmlformats.org/officeDocument/2006/relationships">
   <p:cSld>
     <p:bg>
       <p:bgPr>
@@ -9677,14 +8677,7 @@
         <p:cNvGrpSpPr/>
         <p:nvPr/>
       </p:nvGrpSpPr>
-      <p:grpSpPr>
-        <a:xfrm>
-          <a:off x="0" y="0"/>
-          <a:ext cx="0" cy="0"/>
-          <a:chOff x="0" y="0"/>
-          <a:chExt cx="0" cy="0"/>
-        </a:xfrm>
-      </p:grpSpPr>
+      <p:grpSpPr/>
       <p:sp>
         <p:nvSpPr>
           <p:cNvPr id="2" name="TextBox 1"/>
@@ -9760,7 +8753,6 @@
           <a:lstStyle/>
           <a:p>
             <a:pPr algn="ctr"/>
-            <a:endParaRPr/>
           </a:p>
         </p:txBody>
       </p:sp>

</xml_diff>